<commit_message>
Add screenshot placeholder slides to DMAIC presentation (slides 12-14)
Three new slides with labelled placeholders for workflow screenshots:
Zapier Phase 1, n8n Phase 2a (v1 + v2), n8n current state.
Includes node legend and status summary bar.

https://claude.ai/code/session_011nRTEEcniL9Xx4HAx6p44m
</commit_message>
<xml_diff>
--- a/KI_Auftragsannahme_DMAIC.pptx
+++ b/KI_Auftragsannahme_DMAIC.pptx
@@ -16,6 +16,9 @@
     <p:sldId id="264" r:id="rId15"/>
     <p:sldId id="265" r:id="rId16"/>
     <p:sldId id="266" r:id="rId17"/>
+    <p:sldId id="267" r:id="rId18"/>
+    <p:sldId id="268" r:id="rId19"/>
+    <p:sldId id="269" r:id="rId20"/>
   </p:sldIdLst>
   <p:sldSz cx="12188952" cy="6858000" type="screen4x3"/>
   <p:notesSz cx="6858000" cy="9144000"/>
@@ -5900,6 +5903,2178 @@
                 </a:solidFill>
               </a:rPr>
               <a:t>Schellenberg Druck AG · Schützenhausstrasse 5 · 8330 Pfäffikon · schellenbergdruck.ch  |  Juni 2026</a:t>
+            </a:r>
+          </a:p>
+        </p:txBody>
+      </p:sp>
+    </p:spTree>
+  </p:cSld>
+  <p:clrMapOvr>
+    <a:masterClrMapping/>
+  </p:clrMapOvr>
+</p:sld>
+</file>
+
+<file path=ppt/slides/slide12.xml><?xml version="1.0" encoding="utf-8"?>
+<p:sld xmlns:a="http://schemas.openxmlformats.org/drawingml/2006/main" xmlns:p="http://schemas.openxmlformats.org/presentationml/2006/main" xmlns:r="http://schemas.openxmlformats.org/officeDocument/2006/relationships">
+  <p:cSld>
+    <p:bg>
+      <p:bgPr>
+        <a:solidFill>
+          <a:srgbClr val="F7F9FC"/>
+        </a:solidFill>
+        <a:effectLst/>
+      </p:bgPr>
+    </p:bg>
+    <p:spTree>
+      <p:nvGrpSpPr>
+        <p:cNvPr id="1" name=""/>
+        <p:cNvGrpSpPr/>
+        <p:nvPr/>
+      </p:nvGrpSpPr>
+      <p:grpSpPr/>
+      <p:sp>
+        <p:nvSpPr>
+          <p:cNvPr id="2" name="Rectangle 1"/>
+          <p:cNvSpPr/>
+          <p:nvPr/>
+        </p:nvSpPr>
+        <p:spPr>
+          <a:xfrm>
+            <a:off x="0" y="0"/>
+            <a:ext cx="12188952" cy="73152"/>
+          </a:xfrm>
+          <a:prstGeom prst="rect">
+            <a:avLst/>
+          </a:prstGeom>
+          <a:solidFill>
+            <a:srgbClr val="E85D04"/>
+          </a:solidFill>
+          <a:ln>
+            <a:noFill/>
+          </a:ln>
+        </p:spPr>
+        <p:style>
+          <a:lnRef idx="1">
+            <a:schemeClr val="accent1"/>
+          </a:lnRef>
+          <a:fillRef idx="3">
+            <a:schemeClr val="accent1"/>
+          </a:fillRef>
+          <a:effectRef idx="2">
+            <a:schemeClr val="accent1"/>
+          </a:effectRef>
+          <a:fontRef idx="minor">
+            <a:schemeClr val="lt1"/>
+          </a:fontRef>
+        </p:style>
+        <p:txBody>
+          <a:bodyPr rtlCol="0" anchor="ctr"/>
+          <a:lstStyle/>
+          <a:p>
+            <a:pPr algn="ctr"/>
+          </a:p>
+        </p:txBody>
+      </p:sp>
+      <p:sp>
+        <p:nvSpPr>
+          <p:cNvPr id="3" name="TextBox 2"/>
+          <p:cNvSpPr txBox="1"/>
+          <p:nvPr/>
+        </p:nvSpPr>
+        <p:spPr>
+          <a:xfrm>
+            <a:off x="548640" y="182880"/>
+            <a:ext cx="10972800" cy="594360"/>
+          </a:xfrm>
+          <a:prstGeom prst="rect">
+            <a:avLst/>
+          </a:prstGeom>
+          <a:noFill/>
+        </p:spPr>
+        <p:txBody>
+          <a:bodyPr wrap="square">
+            <a:spAutoFit/>
+          </a:bodyPr>
+          <a:lstStyle/>
+          <a:p>
+            <a:pPr algn="l"/>
+            <a:r>
+              <a:rPr sz="2800" b="1" i="0">
+                <a:solidFill>
+                  <a:srgbClr val="1A202C"/>
+                </a:solidFill>
+              </a:rPr>
+              <a:t>Workflow Evolution – Phase 1: Zapier</a:t>
+            </a:r>
+          </a:p>
+        </p:txBody>
+      </p:sp>
+      <p:sp>
+        <p:nvSpPr>
+          <p:cNvPr id="4" name="TextBox 3"/>
+          <p:cNvSpPr txBox="1"/>
+          <p:nvPr/>
+        </p:nvSpPr>
+        <p:spPr>
+          <a:xfrm>
+            <a:off x="548640" y="804672"/>
+            <a:ext cx="10972800" cy="347472"/>
+          </a:xfrm>
+          <a:prstGeom prst="rect">
+            <a:avLst/>
+          </a:prstGeom>
+          <a:noFill/>
+        </p:spPr>
+        <p:txBody>
+          <a:bodyPr wrap="square">
+            <a:spAutoFit/>
+          </a:bodyPr>
+          <a:lstStyle/>
+          <a:p>
+            <a:pPr algn="l"/>
+            <a:r>
+              <a:rPr sz="1300" b="0" i="0">
+                <a:solidFill>
+                  <a:srgbClr val="4A5568"/>
+                </a:solidFill>
+              </a:rPr>
+              <a:t>Erster funktionsfähiger Workflow | Gmail → AI → Kalkulation → HitL → Versand</a:t>
+            </a:r>
+          </a:p>
+        </p:txBody>
+      </p:sp>
+      <p:sp>
+        <p:nvSpPr>
+          <p:cNvPr id="5" name="Rectangle 4"/>
+          <p:cNvSpPr/>
+          <p:nvPr/>
+        </p:nvSpPr>
+        <p:spPr>
+          <a:xfrm>
+            <a:off x="457200" y="1280160"/>
+            <a:ext cx="11247120" cy="4526280"/>
+          </a:xfrm>
+          <a:prstGeom prst="rect">
+            <a:avLst/>
+          </a:prstGeom>
+          <a:solidFill>
+            <a:srgbClr val="EDF2F7"/>
+          </a:solidFill>
+          <a:ln w="15240">
+            <a:solidFill>
+              <a:srgbClr val="CBD5E0"/>
+            </a:solidFill>
+          </a:ln>
+        </p:spPr>
+        <p:style>
+          <a:lnRef idx="1">
+            <a:schemeClr val="accent1"/>
+          </a:lnRef>
+          <a:fillRef idx="3">
+            <a:schemeClr val="accent1"/>
+          </a:fillRef>
+          <a:effectRef idx="2">
+            <a:schemeClr val="accent1"/>
+          </a:effectRef>
+          <a:fontRef idx="minor">
+            <a:schemeClr val="lt1"/>
+          </a:fontRef>
+        </p:style>
+        <p:txBody>
+          <a:bodyPr rtlCol="0" anchor="ctr"/>
+          <a:lstStyle/>
+          <a:p>
+            <a:pPr algn="ctr"/>
+          </a:p>
+        </p:txBody>
+      </p:sp>
+      <p:sp>
+        <p:nvSpPr>
+          <p:cNvPr id="6" name="TextBox 5"/>
+          <p:cNvSpPr txBox="1"/>
+          <p:nvPr/>
+        </p:nvSpPr>
+        <p:spPr>
+          <a:xfrm>
+            <a:off x="4114800" y="2286000"/>
+            <a:ext cx="4114800" cy="457200"/>
+          </a:xfrm>
+          <a:prstGeom prst="rect">
+            <a:avLst/>
+          </a:prstGeom>
+          <a:noFill/>
+        </p:spPr>
+        <p:txBody>
+          <a:bodyPr wrap="square">
+            <a:spAutoFit/>
+          </a:bodyPr>
+          <a:lstStyle/>
+          <a:p>
+            <a:pPr algn="ctr"/>
+            <a:r>
+              <a:rPr sz="1400" b="0" i="0">
+                <a:solidFill>
+                  <a:srgbClr val="4A5568"/>
+                </a:solidFill>
+              </a:rPr>
+              <a:t>📸  Screenshot einfügen:</a:t>
+            </a:r>
+          </a:p>
+        </p:txBody>
+      </p:sp>
+      <p:sp>
+        <p:nvSpPr>
+          <p:cNvPr id="7" name="TextBox 6"/>
+          <p:cNvSpPr txBox="1"/>
+          <p:nvPr/>
+        </p:nvSpPr>
+        <p:spPr>
+          <a:xfrm>
+            <a:off x="3200400" y="2834640"/>
+            <a:ext cx="5943600" cy="822960"/>
+          </a:xfrm>
+          <a:prstGeom prst="rect">
+            <a:avLst/>
+          </a:prstGeom>
+          <a:noFill/>
+        </p:spPr>
+        <p:txBody>
+          <a:bodyPr wrap="square">
+            <a:spAutoFit/>
+          </a:bodyPr>
+          <a:lstStyle/>
+          <a:p>
+            <a:pPr algn="ctr"/>
+            <a:r>
+              <a:rPr sz="1300" b="0" i="1">
+                <a:solidFill>
+                  <a:srgbClr val="A0AEC0"/>
+                </a:solidFill>
+              </a:rPr>
+              <a:t>Zapier Workflow Übersicht
+(erster Screenshot aus Chatverlauf)</a:t>
+            </a:r>
+          </a:p>
+        </p:txBody>
+      </p:sp>
+      <p:sp>
+        <p:nvSpPr>
+          <p:cNvPr id="8" name="Rectangle 7"/>
+          <p:cNvSpPr/>
+          <p:nvPr/>
+        </p:nvSpPr>
+        <p:spPr>
+          <a:xfrm>
+            <a:off x="457200" y="5943600"/>
+            <a:ext cx="2011680" cy="731520"/>
+          </a:xfrm>
+          <a:prstGeom prst="rect">
+            <a:avLst/>
+          </a:prstGeom>
+          <a:solidFill>
+            <a:srgbClr val="EBF4FF"/>
+          </a:solidFill>
+          <a:ln w="15240">
+            <a:solidFill>
+              <a:srgbClr val="3182CE"/>
+            </a:solidFill>
+          </a:ln>
+        </p:spPr>
+        <p:style>
+          <a:lnRef idx="1">
+            <a:schemeClr val="accent1"/>
+          </a:lnRef>
+          <a:fillRef idx="3">
+            <a:schemeClr val="accent1"/>
+          </a:fillRef>
+          <a:effectRef idx="2">
+            <a:schemeClr val="accent1"/>
+          </a:effectRef>
+          <a:fontRef idx="minor">
+            <a:schemeClr val="lt1"/>
+          </a:fontRef>
+        </p:style>
+        <p:txBody>
+          <a:bodyPr rtlCol="0" anchor="ctr"/>
+          <a:lstStyle/>
+          <a:p>
+            <a:pPr algn="ctr"/>
+          </a:p>
+        </p:txBody>
+      </p:sp>
+      <p:sp>
+        <p:nvSpPr>
+          <p:cNvPr id="9" name="TextBox 8"/>
+          <p:cNvSpPr txBox="1"/>
+          <p:nvPr/>
+        </p:nvSpPr>
+        <p:spPr>
+          <a:xfrm>
+            <a:off x="548640" y="5989320"/>
+            <a:ext cx="1828800" cy="274320"/>
+          </a:xfrm>
+          <a:prstGeom prst="rect">
+            <a:avLst/>
+          </a:prstGeom>
+          <a:noFill/>
+        </p:spPr>
+        <p:txBody>
+          <a:bodyPr wrap="square">
+            <a:spAutoFit/>
+          </a:bodyPr>
+          <a:lstStyle/>
+          <a:p>
+            <a:pPr algn="l"/>
+            <a:r>
+              <a:rPr sz="1000" b="1" i="0">
+                <a:solidFill>
+                  <a:srgbClr val="3182CE"/>
+                </a:solidFill>
+              </a:rPr>
+              <a:t>Step 1–2</a:t>
+            </a:r>
+          </a:p>
+        </p:txBody>
+      </p:sp>
+      <p:sp>
+        <p:nvSpPr>
+          <p:cNvPr id="10" name="TextBox 9"/>
+          <p:cNvSpPr txBox="1"/>
+          <p:nvPr/>
+        </p:nvSpPr>
+        <p:spPr>
+          <a:xfrm>
+            <a:off x="548640" y="6263640"/>
+            <a:ext cx="1828800" cy="320040"/>
+          </a:xfrm>
+          <a:prstGeom prst="rect">
+            <a:avLst/>
+          </a:prstGeom>
+          <a:noFill/>
+        </p:spPr>
+        <p:txBody>
+          <a:bodyPr wrap="square">
+            <a:spAutoFit/>
+          </a:bodyPr>
+          <a:lstStyle/>
+          <a:p>
+            <a:pPr algn="l"/>
+            <a:r>
+              <a:rPr sz="1000" b="0" i="0">
+                <a:solidFill>
+                  <a:srgbClr val="4A5568"/>
+                </a:solidFill>
+              </a:rPr>
+              <a:t>Gmail Trigger
++ AI Analyse</a:t>
+            </a:r>
+          </a:p>
+        </p:txBody>
+      </p:sp>
+      <p:sp>
+        <p:nvSpPr>
+          <p:cNvPr id="11" name="Rectangle 10"/>
+          <p:cNvSpPr/>
+          <p:nvPr/>
+        </p:nvSpPr>
+        <p:spPr>
+          <a:xfrm>
+            <a:off x="2624328" y="5943600"/>
+            <a:ext cx="2011680" cy="731520"/>
+          </a:xfrm>
+          <a:prstGeom prst="rect">
+            <a:avLst/>
+          </a:prstGeom>
+          <a:solidFill>
+            <a:srgbClr val="EBF4FF"/>
+          </a:solidFill>
+          <a:ln w="15240">
+            <a:solidFill>
+              <a:srgbClr val="3182CE"/>
+            </a:solidFill>
+          </a:ln>
+        </p:spPr>
+        <p:style>
+          <a:lnRef idx="1">
+            <a:schemeClr val="accent1"/>
+          </a:lnRef>
+          <a:fillRef idx="3">
+            <a:schemeClr val="accent1"/>
+          </a:fillRef>
+          <a:effectRef idx="2">
+            <a:schemeClr val="accent1"/>
+          </a:effectRef>
+          <a:fontRef idx="minor">
+            <a:schemeClr val="lt1"/>
+          </a:fontRef>
+        </p:style>
+        <p:txBody>
+          <a:bodyPr rtlCol="0" anchor="ctr"/>
+          <a:lstStyle/>
+          <a:p>
+            <a:pPr algn="ctr"/>
+          </a:p>
+        </p:txBody>
+      </p:sp>
+      <p:sp>
+        <p:nvSpPr>
+          <p:cNvPr id="12" name="TextBox 11"/>
+          <p:cNvSpPr txBox="1"/>
+          <p:nvPr/>
+        </p:nvSpPr>
+        <p:spPr>
+          <a:xfrm>
+            <a:off x="2715768" y="5989320"/>
+            <a:ext cx="1828800" cy="274320"/>
+          </a:xfrm>
+          <a:prstGeom prst="rect">
+            <a:avLst/>
+          </a:prstGeom>
+          <a:noFill/>
+        </p:spPr>
+        <p:txBody>
+          <a:bodyPr wrap="square">
+            <a:spAutoFit/>
+          </a:bodyPr>
+          <a:lstStyle/>
+          <a:p>
+            <a:pPr algn="l"/>
+            <a:r>
+              <a:rPr sz="1000" b="1" i="0">
+                <a:solidFill>
+                  <a:srgbClr val="3182CE"/>
+                </a:solidFill>
+              </a:rPr>
+              <a:t>Step 3</a:t>
+            </a:r>
+          </a:p>
+        </p:txBody>
+      </p:sp>
+      <p:sp>
+        <p:nvSpPr>
+          <p:cNvPr id="13" name="TextBox 12"/>
+          <p:cNvSpPr txBox="1"/>
+          <p:nvPr/>
+        </p:nvSpPr>
+        <p:spPr>
+          <a:xfrm>
+            <a:off x="2715768" y="6263640"/>
+            <a:ext cx="1828800" cy="320040"/>
+          </a:xfrm>
+          <a:prstGeom prst="rect">
+            <a:avLst/>
+          </a:prstGeom>
+          <a:noFill/>
+        </p:spPr>
+        <p:txBody>
+          <a:bodyPr wrap="square">
+            <a:spAutoFit/>
+          </a:bodyPr>
+          <a:lstStyle/>
+          <a:p>
+            <a:pPr algn="l"/>
+            <a:r>
+              <a:rPr sz="1000" b="0" i="0">
+                <a:solidFill>
+                  <a:srgbClr val="4A5568"/>
+                </a:solidFill>
+              </a:rPr>
+              <a:t>Path: vollständig
+vs. unvollständig</a:t>
+            </a:r>
+          </a:p>
+        </p:txBody>
+      </p:sp>
+      <p:sp>
+        <p:nvSpPr>
+          <p:cNvPr id="14" name="Rectangle 13"/>
+          <p:cNvSpPr/>
+          <p:nvPr/>
+        </p:nvSpPr>
+        <p:spPr>
+          <a:xfrm>
+            <a:off x="4791456" y="5943600"/>
+            <a:ext cx="2011680" cy="731520"/>
+          </a:xfrm>
+          <a:prstGeom prst="rect">
+            <a:avLst/>
+          </a:prstGeom>
+          <a:solidFill>
+            <a:srgbClr val="EBF4FF"/>
+          </a:solidFill>
+          <a:ln w="15240">
+            <a:solidFill>
+              <a:srgbClr val="3182CE"/>
+            </a:solidFill>
+          </a:ln>
+        </p:spPr>
+        <p:style>
+          <a:lnRef idx="1">
+            <a:schemeClr val="accent1"/>
+          </a:lnRef>
+          <a:fillRef idx="3">
+            <a:schemeClr val="accent1"/>
+          </a:fillRef>
+          <a:effectRef idx="2">
+            <a:schemeClr val="accent1"/>
+          </a:effectRef>
+          <a:fontRef idx="minor">
+            <a:schemeClr val="lt1"/>
+          </a:fontRef>
+        </p:style>
+        <p:txBody>
+          <a:bodyPr rtlCol="0" anchor="ctr"/>
+          <a:lstStyle/>
+          <a:p>
+            <a:pPr algn="ctr"/>
+          </a:p>
+        </p:txBody>
+      </p:sp>
+      <p:sp>
+        <p:nvSpPr>
+          <p:cNvPr id="15" name="TextBox 14"/>
+          <p:cNvSpPr txBox="1"/>
+          <p:nvPr/>
+        </p:nvSpPr>
+        <p:spPr>
+          <a:xfrm>
+            <a:off x="4882896" y="5989320"/>
+            <a:ext cx="1828800" cy="274320"/>
+          </a:xfrm>
+          <a:prstGeom prst="rect">
+            <a:avLst/>
+          </a:prstGeom>
+          <a:noFill/>
+        </p:spPr>
+        <p:txBody>
+          <a:bodyPr wrap="square">
+            <a:spAutoFit/>
+          </a:bodyPr>
+          <a:lstStyle/>
+          <a:p>
+            <a:pPr algn="l"/>
+            <a:r>
+              <a:rPr sz="1000" b="1" i="0">
+                <a:solidFill>
+                  <a:srgbClr val="3182CE"/>
+                </a:solidFill>
+              </a:rPr>
+              <a:t>Step 6–7</a:t>
+            </a:r>
+          </a:p>
+        </p:txBody>
+      </p:sp>
+      <p:sp>
+        <p:nvSpPr>
+          <p:cNvPr id="16" name="TextBox 15"/>
+          <p:cNvSpPr txBox="1"/>
+          <p:nvPr/>
+        </p:nvSpPr>
+        <p:spPr>
+          <a:xfrm>
+            <a:off x="4882896" y="6263640"/>
+            <a:ext cx="1828800" cy="320040"/>
+          </a:xfrm>
+          <a:prstGeom prst="rect">
+            <a:avLst/>
+          </a:prstGeom>
+          <a:noFill/>
+        </p:spPr>
+        <p:txBody>
+          <a:bodyPr wrap="square">
+            <a:spAutoFit/>
+          </a:bodyPr>
+          <a:lstStyle/>
+          <a:p>
+            <a:pPr algn="l"/>
+            <a:r>
+              <a:rPr sz="1000" b="0" i="0">
+                <a:solidFill>
+                  <a:srgbClr val="4A5568"/>
+                </a:solidFill>
+              </a:rPr>
+              <a:t>Kalkulation
++ Offerte AI</a:t>
+            </a:r>
+          </a:p>
+        </p:txBody>
+      </p:sp>
+      <p:sp>
+        <p:nvSpPr>
+          <p:cNvPr id="17" name="Rectangle 16"/>
+          <p:cNvSpPr/>
+          <p:nvPr/>
+        </p:nvSpPr>
+        <p:spPr>
+          <a:xfrm>
+            <a:off x="6958584" y="5943600"/>
+            <a:ext cx="2011680" cy="731520"/>
+          </a:xfrm>
+          <a:prstGeom prst="rect">
+            <a:avLst/>
+          </a:prstGeom>
+          <a:solidFill>
+            <a:srgbClr val="EBF4FF"/>
+          </a:solidFill>
+          <a:ln w="15240">
+            <a:solidFill>
+              <a:srgbClr val="3182CE"/>
+            </a:solidFill>
+          </a:ln>
+        </p:spPr>
+        <p:style>
+          <a:lnRef idx="1">
+            <a:schemeClr val="accent1"/>
+          </a:lnRef>
+          <a:fillRef idx="3">
+            <a:schemeClr val="accent1"/>
+          </a:fillRef>
+          <a:effectRef idx="2">
+            <a:schemeClr val="accent1"/>
+          </a:effectRef>
+          <a:fontRef idx="minor">
+            <a:schemeClr val="lt1"/>
+          </a:fontRef>
+        </p:style>
+        <p:txBody>
+          <a:bodyPr rtlCol="0" anchor="ctr"/>
+          <a:lstStyle/>
+          <a:p>
+            <a:pPr algn="ctr"/>
+          </a:p>
+        </p:txBody>
+      </p:sp>
+      <p:sp>
+        <p:nvSpPr>
+          <p:cNvPr id="18" name="TextBox 17"/>
+          <p:cNvSpPr txBox="1"/>
+          <p:nvPr/>
+        </p:nvSpPr>
+        <p:spPr>
+          <a:xfrm>
+            <a:off x="7050024" y="5989320"/>
+            <a:ext cx="1828800" cy="274320"/>
+          </a:xfrm>
+          <a:prstGeom prst="rect">
+            <a:avLst/>
+          </a:prstGeom>
+          <a:noFill/>
+        </p:spPr>
+        <p:txBody>
+          <a:bodyPr wrap="square">
+            <a:spAutoFit/>
+          </a:bodyPr>
+          <a:lstStyle/>
+          <a:p>
+            <a:pPr algn="l"/>
+            <a:r>
+              <a:rPr sz="1000" b="1" i="0">
+                <a:solidFill>
+                  <a:srgbClr val="3182CE"/>
+                </a:solidFill>
+              </a:rPr>
+              <a:t>Step 9</a:t>
+            </a:r>
+          </a:p>
+        </p:txBody>
+      </p:sp>
+      <p:sp>
+        <p:nvSpPr>
+          <p:cNvPr id="19" name="TextBox 18"/>
+          <p:cNvSpPr txBox="1"/>
+          <p:nvPr/>
+        </p:nvSpPr>
+        <p:spPr>
+          <a:xfrm>
+            <a:off x="7050024" y="6263640"/>
+            <a:ext cx="1828800" cy="320040"/>
+          </a:xfrm>
+          <a:prstGeom prst="rect">
+            <a:avLst/>
+          </a:prstGeom>
+          <a:noFill/>
+        </p:spPr>
+        <p:txBody>
+          <a:bodyPr wrap="square">
+            <a:spAutoFit/>
+          </a:bodyPr>
+          <a:lstStyle/>
+          <a:p>
+            <a:pPr algn="l"/>
+            <a:r>
+              <a:rPr sz="1000" b="0" i="0">
+                <a:solidFill>
+                  <a:srgbClr val="4A5568"/>
+                </a:solidFill>
+              </a:rPr>
+              <a:t>Human in
+the Loop</a:t>
+            </a:r>
+          </a:p>
+        </p:txBody>
+      </p:sp>
+      <p:sp>
+        <p:nvSpPr>
+          <p:cNvPr id="20" name="Rectangle 19"/>
+          <p:cNvSpPr/>
+          <p:nvPr/>
+        </p:nvSpPr>
+        <p:spPr>
+          <a:xfrm>
+            <a:off x="9125712" y="5943600"/>
+            <a:ext cx="2011680" cy="731520"/>
+          </a:xfrm>
+          <a:prstGeom prst="rect">
+            <a:avLst/>
+          </a:prstGeom>
+          <a:solidFill>
+            <a:srgbClr val="EBF4FF"/>
+          </a:solidFill>
+          <a:ln w="15240">
+            <a:solidFill>
+              <a:srgbClr val="3182CE"/>
+            </a:solidFill>
+          </a:ln>
+        </p:spPr>
+        <p:style>
+          <a:lnRef idx="1">
+            <a:schemeClr val="accent1"/>
+          </a:lnRef>
+          <a:fillRef idx="3">
+            <a:schemeClr val="accent1"/>
+          </a:fillRef>
+          <a:effectRef idx="2">
+            <a:schemeClr val="accent1"/>
+          </a:effectRef>
+          <a:fontRef idx="minor">
+            <a:schemeClr val="lt1"/>
+          </a:fontRef>
+        </p:style>
+        <p:txBody>
+          <a:bodyPr rtlCol="0" anchor="ctr"/>
+          <a:lstStyle/>
+          <a:p>
+            <a:pPr algn="ctr"/>
+          </a:p>
+        </p:txBody>
+      </p:sp>
+      <p:sp>
+        <p:nvSpPr>
+          <p:cNvPr id="21" name="TextBox 20"/>
+          <p:cNvSpPr txBox="1"/>
+          <p:nvPr/>
+        </p:nvSpPr>
+        <p:spPr>
+          <a:xfrm>
+            <a:off x="9217152" y="5989320"/>
+            <a:ext cx="1828800" cy="274320"/>
+          </a:xfrm>
+          <a:prstGeom prst="rect">
+            <a:avLst/>
+          </a:prstGeom>
+          <a:noFill/>
+        </p:spPr>
+        <p:txBody>
+          <a:bodyPr wrap="square">
+            <a:spAutoFit/>
+          </a:bodyPr>
+          <a:lstStyle/>
+          <a:p>
+            <a:pPr algn="l"/>
+            <a:r>
+              <a:rPr sz="1000" b="1" i="0">
+                <a:solidFill>
+                  <a:srgbClr val="3182CE"/>
+                </a:solidFill>
+              </a:rPr>
+              <a:t>Step 16</a:t>
+            </a:r>
+          </a:p>
+        </p:txBody>
+      </p:sp>
+      <p:sp>
+        <p:nvSpPr>
+          <p:cNvPr id="22" name="TextBox 21"/>
+          <p:cNvSpPr txBox="1"/>
+          <p:nvPr/>
+        </p:nvSpPr>
+        <p:spPr>
+          <a:xfrm>
+            <a:off x="9217152" y="6263640"/>
+            <a:ext cx="1828800" cy="320040"/>
+          </a:xfrm>
+          <a:prstGeom prst="rect">
+            <a:avLst/>
+          </a:prstGeom>
+          <a:noFill/>
+        </p:spPr>
+        <p:txBody>
+          <a:bodyPr wrap="square">
+            <a:spAutoFit/>
+          </a:bodyPr>
+          <a:lstStyle/>
+          <a:p>
+            <a:pPr algn="l"/>
+            <a:r>
+              <a:rPr sz="1000" b="0" i="0">
+                <a:solidFill>
+                  <a:srgbClr val="4A5568"/>
+                </a:solidFill>
+              </a:rPr>
+              <a:t>Rückfrage
+E-Mail</a:t>
+            </a:r>
+          </a:p>
+        </p:txBody>
+      </p:sp>
+    </p:spTree>
+  </p:cSld>
+  <p:clrMapOvr>
+    <a:masterClrMapping/>
+  </p:clrMapOvr>
+</p:sld>
+</file>
+
+<file path=ppt/slides/slide13.xml><?xml version="1.0" encoding="utf-8"?>
+<p:sld xmlns:a="http://schemas.openxmlformats.org/drawingml/2006/main" xmlns:p="http://schemas.openxmlformats.org/presentationml/2006/main" xmlns:r="http://schemas.openxmlformats.org/officeDocument/2006/relationships">
+  <p:cSld>
+    <p:bg>
+      <p:bgPr>
+        <a:solidFill>
+          <a:srgbClr val="F7F9FC"/>
+        </a:solidFill>
+        <a:effectLst/>
+      </p:bgPr>
+    </p:bg>
+    <p:spTree>
+      <p:nvGrpSpPr>
+        <p:cNvPr id="1" name=""/>
+        <p:cNvGrpSpPr/>
+        <p:nvPr/>
+      </p:nvGrpSpPr>
+      <p:grpSpPr/>
+      <p:sp>
+        <p:nvSpPr>
+          <p:cNvPr id="2" name="Rectangle 1"/>
+          <p:cNvSpPr/>
+          <p:nvPr/>
+        </p:nvSpPr>
+        <p:spPr>
+          <a:xfrm>
+            <a:off x="0" y="0"/>
+            <a:ext cx="12188952" cy="73152"/>
+          </a:xfrm>
+          <a:prstGeom prst="rect">
+            <a:avLst/>
+          </a:prstGeom>
+          <a:solidFill>
+            <a:srgbClr val="E85D04"/>
+          </a:solidFill>
+          <a:ln>
+            <a:noFill/>
+          </a:ln>
+        </p:spPr>
+        <p:style>
+          <a:lnRef idx="1">
+            <a:schemeClr val="accent1"/>
+          </a:lnRef>
+          <a:fillRef idx="3">
+            <a:schemeClr val="accent1"/>
+          </a:fillRef>
+          <a:effectRef idx="2">
+            <a:schemeClr val="accent1"/>
+          </a:effectRef>
+          <a:fontRef idx="minor">
+            <a:schemeClr val="lt1"/>
+          </a:fontRef>
+        </p:style>
+        <p:txBody>
+          <a:bodyPr rtlCol="0" anchor="ctr"/>
+          <a:lstStyle/>
+          <a:p>
+            <a:pPr algn="ctr"/>
+          </a:p>
+        </p:txBody>
+      </p:sp>
+      <p:sp>
+        <p:nvSpPr>
+          <p:cNvPr id="3" name="TextBox 2"/>
+          <p:cNvSpPr txBox="1"/>
+          <p:nvPr/>
+        </p:nvSpPr>
+        <p:spPr>
+          <a:xfrm>
+            <a:off x="548640" y="182880"/>
+            <a:ext cx="10972800" cy="594360"/>
+          </a:xfrm>
+          <a:prstGeom prst="rect">
+            <a:avLst/>
+          </a:prstGeom>
+          <a:noFill/>
+        </p:spPr>
+        <p:txBody>
+          <a:bodyPr wrap="square">
+            <a:spAutoFit/>
+          </a:bodyPr>
+          <a:lstStyle/>
+          <a:p>
+            <a:pPr algn="l"/>
+            <a:r>
+              <a:rPr sz="2800" b="1" i="0">
+                <a:solidFill>
+                  <a:srgbClr val="1A202C"/>
+                </a:solidFill>
+              </a:rPr>
+              <a:t>Workflow Evolution – Phase 2a: n8n Einstieg</a:t>
+            </a:r>
+          </a:p>
+        </p:txBody>
+      </p:sp>
+      <p:sp>
+        <p:nvSpPr>
+          <p:cNvPr id="4" name="TextBox 3"/>
+          <p:cNvSpPr txBox="1"/>
+          <p:nvPr/>
+        </p:nvSpPr>
+        <p:spPr>
+          <a:xfrm>
+            <a:off x="548640" y="804672"/>
+            <a:ext cx="10972800" cy="347472"/>
+          </a:xfrm>
+          <a:prstGeom prst="rect">
+            <a:avLst/>
+          </a:prstGeom>
+          <a:noFill/>
+        </p:spPr>
+        <p:txBody>
+          <a:bodyPr wrap="square">
+            <a:spAutoFit/>
+          </a:bodyPr>
+          <a:lstStyle/>
+          <a:p>
+            <a:pPr algn="l"/>
+            <a:r>
+              <a:rPr sz="1300" b="0" i="0">
+                <a:solidFill>
+                  <a:srgbClr val="4A5568"/>
+                </a:solidFill>
+              </a:rPr>
+              <a:t>Erste n8n Version | Gmail + Webhook → Vollständigkeit → Kalkulation → Google Docs</a:t>
+            </a:r>
+          </a:p>
+        </p:txBody>
+      </p:sp>
+      <p:sp>
+        <p:nvSpPr>
+          <p:cNvPr id="5" name="Rectangle 4"/>
+          <p:cNvSpPr/>
+          <p:nvPr/>
+        </p:nvSpPr>
+        <p:spPr>
+          <a:xfrm>
+            <a:off x="457200" y="1261872"/>
+            <a:ext cx="5440680" cy="4206240"/>
+          </a:xfrm>
+          <a:prstGeom prst="rect">
+            <a:avLst/>
+          </a:prstGeom>
+          <a:solidFill>
+            <a:srgbClr val="EDF2F7"/>
+          </a:solidFill>
+          <a:ln w="15240">
+            <a:solidFill>
+              <a:srgbClr val="CBD5E0"/>
+            </a:solidFill>
+          </a:ln>
+        </p:spPr>
+        <p:style>
+          <a:lnRef idx="1">
+            <a:schemeClr val="accent1"/>
+          </a:lnRef>
+          <a:fillRef idx="3">
+            <a:schemeClr val="accent1"/>
+          </a:fillRef>
+          <a:effectRef idx="2">
+            <a:schemeClr val="accent1"/>
+          </a:effectRef>
+          <a:fontRef idx="minor">
+            <a:schemeClr val="lt1"/>
+          </a:fontRef>
+        </p:style>
+        <p:txBody>
+          <a:bodyPr rtlCol="0" anchor="ctr"/>
+          <a:lstStyle/>
+          <a:p>
+            <a:pPr algn="ctr"/>
+          </a:p>
+        </p:txBody>
+      </p:sp>
+      <p:sp>
+        <p:nvSpPr>
+          <p:cNvPr id="6" name="TextBox 5"/>
+          <p:cNvSpPr txBox="1"/>
+          <p:nvPr/>
+        </p:nvSpPr>
+        <p:spPr>
+          <a:xfrm>
+            <a:off x="914400" y="2377440"/>
+            <a:ext cx="4480560" cy="411480"/>
+          </a:xfrm>
+          <a:prstGeom prst="rect">
+            <a:avLst/>
+          </a:prstGeom>
+          <a:noFill/>
+        </p:spPr>
+        <p:txBody>
+          <a:bodyPr wrap="square">
+            <a:spAutoFit/>
+          </a:bodyPr>
+          <a:lstStyle/>
+          <a:p>
+            <a:pPr algn="ctr"/>
+            <a:r>
+              <a:rPr sz="1300" b="0" i="0">
+                <a:solidFill>
+                  <a:srgbClr val="4A5568"/>
+                </a:solidFill>
+              </a:rPr>
+              <a:t>📸  Screenshot einfügen:</a:t>
+            </a:r>
+          </a:p>
+        </p:txBody>
+      </p:sp>
+      <p:sp>
+        <p:nvSpPr>
+          <p:cNvPr id="7" name="TextBox 6"/>
+          <p:cNvSpPr txBox="1"/>
+          <p:nvPr/>
+        </p:nvSpPr>
+        <p:spPr>
+          <a:xfrm>
+            <a:off x="914400" y="2880360"/>
+            <a:ext cx="4480560" cy="822960"/>
+          </a:xfrm>
+          <a:prstGeom prst="rect">
+            <a:avLst/>
+          </a:prstGeom>
+          <a:noFill/>
+        </p:spPr>
+        <p:txBody>
+          <a:bodyPr wrap="square">
+            <a:spAutoFit/>
+          </a:bodyPr>
+          <a:lstStyle/>
+          <a:p>
+            <a:pPr algn="ctr"/>
+            <a:r>
+              <a:rPr sz="1200" b="0" i="1">
+                <a:solidFill>
+                  <a:srgbClr val="A0AEC0"/>
+                </a:solidFill>
+              </a:rPr>
+              <a:t>n8n Workflow – Version 1
+(2 Kanäle: Gmail + Webhook)
+Screenshot aus Chatverlauf</a:t>
+            </a:r>
+          </a:p>
+        </p:txBody>
+      </p:sp>
+      <p:sp>
+        <p:nvSpPr>
+          <p:cNvPr id="8" name="Rectangle 7"/>
+          <p:cNvSpPr/>
+          <p:nvPr/>
+        </p:nvSpPr>
+        <p:spPr>
+          <a:xfrm>
+            <a:off x="6263640" y="1261872"/>
+            <a:ext cx="5440680" cy="4206240"/>
+          </a:xfrm>
+          <a:prstGeom prst="rect">
+            <a:avLst/>
+          </a:prstGeom>
+          <a:solidFill>
+            <a:srgbClr val="EDF2F7"/>
+          </a:solidFill>
+          <a:ln w="15240">
+            <a:solidFill>
+              <a:srgbClr val="CBD5E0"/>
+            </a:solidFill>
+          </a:ln>
+        </p:spPr>
+        <p:style>
+          <a:lnRef idx="1">
+            <a:schemeClr val="accent1"/>
+          </a:lnRef>
+          <a:fillRef idx="3">
+            <a:schemeClr val="accent1"/>
+          </a:fillRef>
+          <a:effectRef idx="2">
+            <a:schemeClr val="accent1"/>
+          </a:effectRef>
+          <a:fontRef idx="minor">
+            <a:schemeClr val="lt1"/>
+          </a:fontRef>
+        </p:style>
+        <p:txBody>
+          <a:bodyPr rtlCol="0" anchor="ctr"/>
+          <a:lstStyle/>
+          <a:p>
+            <a:pPr algn="ctr"/>
+          </a:p>
+        </p:txBody>
+      </p:sp>
+      <p:sp>
+        <p:nvSpPr>
+          <p:cNvPr id="9" name="TextBox 8"/>
+          <p:cNvSpPr txBox="1"/>
+          <p:nvPr/>
+        </p:nvSpPr>
+        <p:spPr>
+          <a:xfrm>
+            <a:off x="6720840" y="2377440"/>
+            <a:ext cx="4480560" cy="411480"/>
+          </a:xfrm>
+          <a:prstGeom prst="rect">
+            <a:avLst/>
+          </a:prstGeom>
+          <a:noFill/>
+        </p:spPr>
+        <p:txBody>
+          <a:bodyPr wrap="square">
+            <a:spAutoFit/>
+          </a:bodyPr>
+          <a:lstStyle/>
+          <a:p>
+            <a:pPr algn="ctr"/>
+            <a:r>
+              <a:rPr sz="1300" b="0" i="0">
+                <a:solidFill>
+                  <a:srgbClr val="4A5568"/>
+                </a:solidFill>
+              </a:rPr>
+              <a:t>📸  Screenshot einfügen:</a:t>
+            </a:r>
+          </a:p>
+        </p:txBody>
+      </p:sp>
+      <p:sp>
+        <p:nvSpPr>
+          <p:cNvPr id="10" name="TextBox 9"/>
+          <p:cNvSpPr txBox="1"/>
+          <p:nvPr/>
+        </p:nvSpPr>
+        <p:spPr>
+          <a:xfrm>
+            <a:off x="6720840" y="2788920"/>
+            <a:ext cx="4480560" cy="1005840"/>
+          </a:xfrm>
+          <a:prstGeom prst="rect">
+            <a:avLst/>
+          </a:prstGeom>
+          <a:noFill/>
+        </p:spPr>
+        <p:txBody>
+          <a:bodyPr wrap="square">
+            <a:spAutoFit/>
+          </a:bodyPr>
+          <a:lstStyle/>
+          <a:p>
+            <a:pPr algn="ctr"/>
+            <a:r>
+              <a:rPr sz="1200" b="0" i="1">
+                <a:solidFill>
+                  <a:srgbClr val="A0AEC0"/>
+                </a:solidFill>
+              </a:rPr>
+              <a:t>n8n Workflow – Version 2
+(6 Kanäle: + Twilio, WhatsApp,
+Telegram, Kontaktformular)
+Screenshot aus Chatverlauf</a:t>
+            </a:r>
+          </a:p>
+        </p:txBody>
+      </p:sp>
+      <p:sp>
+        <p:nvSpPr>
+          <p:cNvPr id="11" name="Rectangle 10"/>
+          <p:cNvSpPr/>
+          <p:nvPr/>
+        </p:nvSpPr>
+        <p:spPr>
+          <a:xfrm>
+            <a:off x="457200" y="5623560"/>
+            <a:ext cx="5440680" cy="1005840"/>
+          </a:xfrm>
+          <a:prstGeom prst="rect">
+            <a:avLst/>
+          </a:prstGeom>
+          <a:solidFill>
+            <a:srgbClr val="EAF7EE"/>
+          </a:solidFill>
+          <a:ln w="15240">
+            <a:solidFill>
+              <a:srgbClr val="38A169"/>
+            </a:solidFill>
+          </a:ln>
+        </p:spPr>
+        <p:style>
+          <a:lnRef idx="1">
+            <a:schemeClr val="accent1"/>
+          </a:lnRef>
+          <a:fillRef idx="3">
+            <a:schemeClr val="accent1"/>
+          </a:fillRef>
+          <a:effectRef idx="2">
+            <a:schemeClr val="accent1"/>
+          </a:effectRef>
+          <a:fontRef idx="minor">
+            <a:schemeClr val="lt1"/>
+          </a:fontRef>
+        </p:style>
+        <p:txBody>
+          <a:bodyPr rtlCol="0" anchor="ctr"/>
+          <a:lstStyle/>
+          <a:p>
+            <a:pPr algn="ctr"/>
+          </a:p>
+        </p:txBody>
+      </p:sp>
+      <p:sp>
+        <p:nvSpPr>
+          <p:cNvPr id="12" name="TextBox 11"/>
+          <p:cNvSpPr txBox="1"/>
+          <p:nvPr/>
+        </p:nvSpPr>
+        <p:spPr>
+          <a:xfrm>
+            <a:off x="594360" y="5687568"/>
+            <a:ext cx="5120640" cy="292608"/>
+          </a:xfrm>
+          <a:prstGeom prst="rect">
+            <a:avLst/>
+          </a:prstGeom>
+          <a:noFill/>
+        </p:spPr>
+        <p:txBody>
+          <a:bodyPr wrap="square">
+            <a:spAutoFit/>
+          </a:bodyPr>
+          <a:lstStyle/>
+          <a:p>
+            <a:pPr algn="l"/>
+            <a:r>
+              <a:rPr sz="1100" b="1" i="0">
+                <a:solidFill>
+                  <a:srgbClr val="38A169"/>
+                </a:solidFill>
+              </a:rPr>
+              <a:t>Version 1 – 2 Kanäle</a:t>
+            </a:r>
+          </a:p>
+        </p:txBody>
+      </p:sp>
+      <p:sp>
+        <p:nvSpPr>
+          <p:cNvPr id="13" name="TextBox 12"/>
+          <p:cNvSpPr txBox="1"/>
+          <p:nvPr/>
+        </p:nvSpPr>
+        <p:spPr>
+          <a:xfrm>
+            <a:off x="594360" y="6016752"/>
+            <a:ext cx="5120640" cy="502920"/>
+          </a:xfrm>
+          <a:prstGeom prst="rect">
+            <a:avLst/>
+          </a:prstGeom>
+          <a:noFill/>
+        </p:spPr>
+        <p:txBody>
+          <a:bodyPr wrap="square">
+            <a:spAutoFit/>
+          </a:bodyPr>
+          <a:lstStyle/>
+          <a:p>
+            <a:r>
+              <a:rPr sz="1100">
+                <a:solidFill>
+                  <a:srgbClr val="4A5568"/>
+                </a:solidFill>
+              </a:rPr>
+              <a:t>Gmail · Webhook</a:t>
+            </a:r>
+          </a:p>
+        </p:txBody>
+      </p:sp>
+      <p:sp>
+        <p:nvSpPr>
+          <p:cNvPr id="14" name="Rectangle 13"/>
+          <p:cNvSpPr/>
+          <p:nvPr/>
+        </p:nvSpPr>
+        <p:spPr>
+          <a:xfrm>
+            <a:off x="6263640" y="5623560"/>
+            <a:ext cx="5440680" cy="1005840"/>
+          </a:xfrm>
+          <a:prstGeom prst="rect">
+            <a:avLst/>
+          </a:prstGeom>
+          <a:solidFill>
+            <a:srgbClr val="EAF7EE"/>
+          </a:solidFill>
+          <a:ln w="15240">
+            <a:solidFill>
+              <a:srgbClr val="38A169"/>
+            </a:solidFill>
+          </a:ln>
+        </p:spPr>
+        <p:style>
+          <a:lnRef idx="1">
+            <a:schemeClr val="accent1"/>
+          </a:lnRef>
+          <a:fillRef idx="3">
+            <a:schemeClr val="accent1"/>
+          </a:fillRef>
+          <a:effectRef idx="2">
+            <a:schemeClr val="accent1"/>
+          </a:effectRef>
+          <a:fontRef idx="minor">
+            <a:schemeClr val="lt1"/>
+          </a:fontRef>
+        </p:style>
+        <p:txBody>
+          <a:bodyPr rtlCol="0" anchor="ctr"/>
+          <a:lstStyle/>
+          <a:p>
+            <a:pPr algn="ctr"/>
+          </a:p>
+        </p:txBody>
+      </p:sp>
+      <p:sp>
+        <p:nvSpPr>
+          <p:cNvPr id="15" name="TextBox 14"/>
+          <p:cNvSpPr txBox="1"/>
+          <p:nvPr/>
+        </p:nvSpPr>
+        <p:spPr>
+          <a:xfrm>
+            <a:off x="6400800" y="5687568"/>
+            <a:ext cx="5120640" cy="292608"/>
+          </a:xfrm>
+          <a:prstGeom prst="rect">
+            <a:avLst/>
+          </a:prstGeom>
+          <a:noFill/>
+        </p:spPr>
+        <p:txBody>
+          <a:bodyPr wrap="square">
+            <a:spAutoFit/>
+          </a:bodyPr>
+          <a:lstStyle/>
+          <a:p>
+            <a:pPr algn="l"/>
+            <a:r>
+              <a:rPr sz="1100" b="1" i="0">
+                <a:solidFill>
+                  <a:srgbClr val="38A169"/>
+                </a:solidFill>
+              </a:rPr>
+              <a:t>Version 2 – 6 Kanäle</a:t>
+            </a:r>
+          </a:p>
+        </p:txBody>
+      </p:sp>
+      <p:sp>
+        <p:nvSpPr>
+          <p:cNvPr id="16" name="TextBox 15"/>
+          <p:cNvSpPr txBox="1"/>
+          <p:nvPr/>
+        </p:nvSpPr>
+        <p:spPr>
+          <a:xfrm>
+            <a:off x="6400800" y="6016752"/>
+            <a:ext cx="5120640" cy="502920"/>
+          </a:xfrm>
+          <a:prstGeom prst="rect">
+            <a:avLst/>
+          </a:prstGeom>
+          <a:noFill/>
+        </p:spPr>
+        <p:txBody>
+          <a:bodyPr wrap="square">
+            <a:spAutoFit/>
+          </a:bodyPr>
+          <a:lstStyle/>
+          <a:p>
+            <a:r>
+              <a:rPr sz="1100">
+                <a:solidFill>
+                  <a:srgbClr val="4A5568"/>
+                </a:solidFill>
+              </a:rPr>
+              <a:t>+ Twilio · WhatsApp · Telegram · Formular</a:t>
+            </a:r>
+          </a:p>
+        </p:txBody>
+      </p:sp>
+    </p:spTree>
+  </p:cSld>
+  <p:clrMapOvr>
+    <a:masterClrMapping/>
+  </p:clrMapOvr>
+</p:sld>
+</file>
+
+<file path=ppt/slides/slide14.xml><?xml version="1.0" encoding="utf-8"?>
+<p:sld xmlns:a="http://schemas.openxmlformats.org/drawingml/2006/main" xmlns:p="http://schemas.openxmlformats.org/presentationml/2006/main" xmlns:r="http://schemas.openxmlformats.org/officeDocument/2006/relationships">
+  <p:cSld>
+    <p:bg>
+      <p:bgPr>
+        <a:solidFill>
+          <a:srgbClr val="F7F9FC"/>
+        </a:solidFill>
+        <a:effectLst/>
+      </p:bgPr>
+    </p:bg>
+    <p:spTree>
+      <p:nvGrpSpPr>
+        <p:cNvPr id="1" name=""/>
+        <p:cNvGrpSpPr/>
+        <p:nvPr/>
+      </p:nvGrpSpPr>
+      <p:grpSpPr/>
+      <p:sp>
+        <p:nvSpPr>
+          <p:cNvPr id="2" name="Rectangle 1"/>
+          <p:cNvSpPr/>
+          <p:nvPr/>
+        </p:nvSpPr>
+        <p:spPr>
+          <a:xfrm>
+            <a:off x="0" y="0"/>
+            <a:ext cx="12188952" cy="73152"/>
+          </a:xfrm>
+          <a:prstGeom prst="rect">
+            <a:avLst/>
+          </a:prstGeom>
+          <a:solidFill>
+            <a:srgbClr val="E85D04"/>
+          </a:solidFill>
+          <a:ln>
+            <a:noFill/>
+          </a:ln>
+        </p:spPr>
+        <p:style>
+          <a:lnRef idx="1">
+            <a:schemeClr val="accent1"/>
+          </a:lnRef>
+          <a:fillRef idx="3">
+            <a:schemeClr val="accent1"/>
+          </a:fillRef>
+          <a:effectRef idx="2">
+            <a:schemeClr val="accent1"/>
+          </a:effectRef>
+          <a:fontRef idx="minor">
+            <a:schemeClr val="lt1"/>
+          </a:fontRef>
+        </p:style>
+        <p:txBody>
+          <a:bodyPr rtlCol="0" anchor="ctr"/>
+          <a:lstStyle/>
+          <a:p>
+            <a:pPr algn="ctr"/>
+          </a:p>
+        </p:txBody>
+      </p:sp>
+      <p:sp>
+        <p:nvSpPr>
+          <p:cNvPr id="3" name="TextBox 2"/>
+          <p:cNvSpPr txBox="1"/>
+          <p:nvPr/>
+        </p:nvSpPr>
+        <p:spPr>
+          <a:xfrm>
+            <a:off x="548640" y="182880"/>
+            <a:ext cx="10972800" cy="594360"/>
+          </a:xfrm>
+          <a:prstGeom prst="rect">
+            <a:avLst/>
+          </a:prstGeom>
+          <a:noFill/>
+        </p:spPr>
+        <p:txBody>
+          <a:bodyPr wrap="square">
+            <a:spAutoFit/>
+          </a:bodyPr>
+          <a:lstStyle/>
+          <a:p>
+            <a:pPr algn="l"/>
+            <a:r>
+              <a:rPr sz="2800" b="1" i="0">
+                <a:solidFill>
+                  <a:srgbClr val="1A202C"/>
+                </a:solidFill>
+              </a:rPr>
+              <a:t>Workflow Evolution – Phase 2b: Aktueller Stand</a:t>
+            </a:r>
+          </a:p>
+        </p:txBody>
+      </p:sp>
+      <p:sp>
+        <p:nvSpPr>
+          <p:cNvPr id="4" name="TextBox 3"/>
+          <p:cNvSpPr txBox="1"/>
+          <p:nvPr/>
+        </p:nvSpPr>
+        <p:spPr>
+          <a:xfrm>
+            <a:off x="548640" y="804672"/>
+            <a:ext cx="10972800" cy="347472"/>
+          </a:xfrm>
+          <a:prstGeom prst="rect">
+            <a:avLst/>
+          </a:prstGeom>
+          <a:noFill/>
+        </p:spPr>
+        <p:txBody>
+          <a:bodyPr wrap="square">
+            <a:spAutoFit/>
+          </a:bodyPr>
+          <a:lstStyle/>
+          <a:p>
+            <a:pPr algn="l"/>
+            <a:r>
+              <a:rPr sz="1300" b="0" i="0">
+                <a:solidFill>
+                  <a:srgbClr val="4A5568"/>
+                </a:solidFill>
+              </a:rPr>
+              <a:t>Vollständiger Workflow mit HitL Wait-Node, Genehmigungspfad und Fehlerbehandlung</a:t>
+            </a:r>
+          </a:p>
+        </p:txBody>
+      </p:sp>
+      <p:sp>
+        <p:nvSpPr>
+          <p:cNvPr id="5" name="Rectangle 4"/>
+          <p:cNvSpPr/>
+          <p:nvPr/>
+        </p:nvSpPr>
+        <p:spPr>
+          <a:xfrm>
+            <a:off x="457200" y="1261872"/>
+            <a:ext cx="7772400" cy="4892040"/>
+          </a:xfrm>
+          <a:prstGeom prst="rect">
+            <a:avLst/>
+          </a:prstGeom>
+          <a:solidFill>
+            <a:srgbClr val="EDF2F7"/>
+          </a:solidFill>
+          <a:ln w="15240">
+            <a:solidFill>
+              <a:srgbClr val="CBD5E0"/>
+            </a:solidFill>
+          </a:ln>
+        </p:spPr>
+        <p:style>
+          <a:lnRef idx="1">
+            <a:schemeClr val="accent1"/>
+          </a:lnRef>
+          <a:fillRef idx="3">
+            <a:schemeClr val="accent1"/>
+          </a:fillRef>
+          <a:effectRef idx="2">
+            <a:schemeClr val="accent1"/>
+          </a:effectRef>
+          <a:fontRef idx="minor">
+            <a:schemeClr val="lt1"/>
+          </a:fontRef>
+        </p:style>
+        <p:txBody>
+          <a:bodyPr rtlCol="0" anchor="ctr"/>
+          <a:lstStyle/>
+          <a:p>
+            <a:pPr algn="ctr"/>
+          </a:p>
+        </p:txBody>
+      </p:sp>
+      <p:sp>
+        <p:nvSpPr>
+          <p:cNvPr id="6" name="TextBox 5"/>
+          <p:cNvSpPr txBox="1"/>
+          <p:nvPr/>
+        </p:nvSpPr>
+        <p:spPr>
+          <a:xfrm>
+            <a:off x="2286000" y="2743200"/>
+            <a:ext cx="4114800" cy="411480"/>
+          </a:xfrm>
+          <a:prstGeom prst="rect">
+            <a:avLst/>
+          </a:prstGeom>
+          <a:noFill/>
+        </p:spPr>
+        <p:txBody>
+          <a:bodyPr wrap="square">
+            <a:spAutoFit/>
+          </a:bodyPr>
+          <a:lstStyle/>
+          <a:p>
+            <a:pPr algn="ctr"/>
+            <a:r>
+              <a:rPr sz="1400" b="0" i="0">
+                <a:solidFill>
+                  <a:srgbClr val="4A5568"/>
+                </a:solidFill>
+              </a:rPr>
+              <a:t>📸  Screenshot einfügen:</a:t>
+            </a:r>
+          </a:p>
+        </p:txBody>
+      </p:sp>
+      <p:sp>
+        <p:nvSpPr>
+          <p:cNvPr id="7" name="TextBox 6"/>
+          <p:cNvSpPr txBox="1"/>
+          <p:nvPr/>
+        </p:nvSpPr>
+        <p:spPr>
+          <a:xfrm>
+            <a:off x="1828800" y="3291840"/>
+            <a:ext cx="5029200" cy="822960"/>
+          </a:xfrm>
+          <a:prstGeom prst="rect">
+            <a:avLst/>
+          </a:prstGeom>
+          <a:noFill/>
+        </p:spPr>
+        <p:txBody>
+          <a:bodyPr wrap="square">
+            <a:spAutoFit/>
+          </a:bodyPr>
+          <a:lstStyle/>
+          <a:p>
+            <a:pPr algn="ctr"/>
+            <a:r>
+              <a:rPr sz="1200" b="0" i="1">
+                <a:solidFill>
+                  <a:srgbClr val="A0AEC0"/>
+                </a:solidFill>
+              </a:rPr>
+              <a:t>n8n Workflow – Aktuellster Stand
+(vollständiger Flow mit allen Nodes)
+Screenshot aus Chatverlauf</a:t>
+            </a:r>
+          </a:p>
+        </p:txBody>
+      </p:sp>
+      <p:sp>
+        <p:nvSpPr>
+          <p:cNvPr id="8" name="Rectangle 7"/>
+          <p:cNvSpPr/>
+          <p:nvPr/>
+        </p:nvSpPr>
+        <p:spPr>
+          <a:xfrm>
+            <a:off x="8503920" y="1261872"/>
+            <a:ext cx="3200400" cy="4892040"/>
+          </a:xfrm>
+          <a:prstGeom prst="rect">
+            <a:avLst/>
+          </a:prstGeom>
+          <a:solidFill>
+            <a:srgbClr val="E0F7FA"/>
+          </a:solidFill>
+          <a:ln w="15240">
+            <a:solidFill>
+              <a:srgbClr val="0096B5"/>
+            </a:solidFill>
+          </a:ln>
+        </p:spPr>
+        <p:style>
+          <a:lnRef idx="1">
+            <a:schemeClr val="accent1"/>
+          </a:lnRef>
+          <a:fillRef idx="3">
+            <a:schemeClr val="accent1"/>
+          </a:fillRef>
+          <a:effectRef idx="2">
+            <a:schemeClr val="accent1"/>
+          </a:effectRef>
+          <a:fontRef idx="minor">
+            <a:schemeClr val="lt1"/>
+          </a:fontRef>
+        </p:style>
+        <p:txBody>
+          <a:bodyPr rtlCol="0" anchor="ctr"/>
+          <a:lstStyle/>
+          <a:p>
+            <a:pPr algn="ctr"/>
+          </a:p>
+        </p:txBody>
+      </p:sp>
+      <p:sp>
+        <p:nvSpPr>
+          <p:cNvPr id="9" name="Rectangle 8"/>
+          <p:cNvSpPr/>
+          <p:nvPr/>
+        </p:nvSpPr>
+        <p:spPr>
+          <a:xfrm>
+            <a:off x="8503920" y="1261872"/>
+            <a:ext cx="3200400" cy="384048"/>
+          </a:xfrm>
+          <a:prstGeom prst="rect">
+            <a:avLst/>
+          </a:prstGeom>
+          <a:solidFill>
+            <a:srgbClr val="0096B5"/>
+          </a:solidFill>
+          <a:ln>
+            <a:noFill/>
+          </a:ln>
+        </p:spPr>
+        <p:style>
+          <a:lnRef idx="1">
+            <a:schemeClr val="accent1"/>
+          </a:lnRef>
+          <a:fillRef idx="3">
+            <a:schemeClr val="accent1"/>
+          </a:fillRef>
+          <a:effectRef idx="2">
+            <a:schemeClr val="accent1"/>
+          </a:effectRef>
+          <a:fontRef idx="minor">
+            <a:schemeClr val="lt1"/>
+          </a:fontRef>
+        </p:style>
+        <p:txBody>
+          <a:bodyPr rtlCol="0" anchor="ctr"/>
+          <a:lstStyle/>
+          <a:p>
+            <a:pPr algn="ctr"/>
+          </a:p>
+        </p:txBody>
+      </p:sp>
+      <p:sp>
+        <p:nvSpPr>
+          <p:cNvPr id="10" name="TextBox 9"/>
+          <p:cNvSpPr txBox="1"/>
+          <p:nvPr/>
+        </p:nvSpPr>
+        <p:spPr>
+          <a:xfrm>
+            <a:off x="8641080" y="1307592"/>
+            <a:ext cx="2926080" cy="292608"/>
+          </a:xfrm>
+          <a:prstGeom prst="rect">
+            <a:avLst/>
+          </a:prstGeom>
+          <a:noFill/>
+        </p:spPr>
+        <p:txBody>
+          <a:bodyPr wrap="square">
+            <a:spAutoFit/>
+          </a:bodyPr>
+          <a:lstStyle/>
+          <a:p>
+            <a:pPr algn="l"/>
+            <a:r>
+              <a:rPr sz="1200" b="1" i="0">
+                <a:solidFill>
+                  <a:srgbClr val="FFFFFF"/>
+                </a:solidFill>
+              </a:rPr>
+              <a:t>Node-Legende</a:t>
+            </a:r>
+          </a:p>
+        </p:txBody>
+      </p:sp>
+      <p:sp>
+        <p:nvSpPr>
+          <p:cNvPr id="11" name="TextBox 10"/>
+          <p:cNvSpPr txBox="1"/>
+          <p:nvPr/>
+        </p:nvSpPr>
+        <p:spPr>
+          <a:xfrm>
+            <a:off x="8641080" y="1783080"/>
+            <a:ext cx="2926080" cy="411480"/>
+          </a:xfrm>
+          <a:prstGeom prst="rect">
+            <a:avLst/>
+          </a:prstGeom>
+          <a:noFill/>
+        </p:spPr>
+        <p:txBody>
+          <a:bodyPr wrap="square">
+            <a:spAutoFit/>
+          </a:bodyPr>
+          <a:lstStyle/>
+          <a:p>
+            <a:pPr algn="l"/>
+            <a:r>
+              <a:rPr sz="1100" b="0" i="0">
+                <a:solidFill>
+                  <a:srgbClr val="1A202C"/>
+                </a:solidFill>
+              </a:rPr>
+              <a:t>📧  Gmail / E-Mail</a:t>
+            </a:r>
+          </a:p>
+        </p:txBody>
+      </p:sp>
+      <p:sp>
+        <p:nvSpPr>
+          <p:cNvPr id="12" name="TextBox 11"/>
+          <p:cNvSpPr txBox="1"/>
+          <p:nvPr/>
+        </p:nvSpPr>
+        <p:spPr>
+          <a:xfrm>
+            <a:off x="8641080" y="2258568"/>
+            <a:ext cx="2926080" cy="411480"/>
+          </a:xfrm>
+          <a:prstGeom prst="rect">
+            <a:avLst/>
+          </a:prstGeom>
+          <a:noFill/>
+        </p:spPr>
+        <p:txBody>
+          <a:bodyPr wrap="square">
+            <a:spAutoFit/>
+          </a:bodyPr>
+          <a:lstStyle/>
+          <a:p>
+            <a:pPr algn="l"/>
+            <a:r>
+              <a:rPr sz="1100" b="0" i="0">
+                <a:solidFill>
+                  <a:srgbClr val="1A202C"/>
+                </a:solidFill>
+              </a:rPr>
+              <a:t>🤖  Claude AI (Anthropic)</a:t>
+            </a:r>
+          </a:p>
+        </p:txBody>
+      </p:sp>
+      <p:sp>
+        <p:nvSpPr>
+          <p:cNvPr id="13" name="TextBox 12"/>
+          <p:cNvSpPr txBox="1"/>
+          <p:nvPr/>
+        </p:nvSpPr>
+        <p:spPr>
+          <a:xfrm>
+            <a:off x="8641080" y="2734056"/>
+            <a:ext cx="2926080" cy="411480"/>
+          </a:xfrm>
+          <a:prstGeom prst="rect">
+            <a:avLst/>
+          </a:prstGeom>
+          <a:noFill/>
+        </p:spPr>
+        <p:txBody>
+          <a:bodyPr wrap="square">
+            <a:spAutoFit/>
+          </a:bodyPr>
+          <a:lstStyle/>
+          <a:p>
+            <a:pPr algn="l"/>
+            <a:r>
+              <a:rPr sz="1100" b="0" i="0">
+                <a:solidFill>
+                  <a:srgbClr val="1A202C"/>
+                </a:solidFill>
+              </a:rPr>
+              <a:t>⚙️  Code / Transform</a:t>
+            </a:r>
+          </a:p>
+        </p:txBody>
+      </p:sp>
+      <p:sp>
+        <p:nvSpPr>
+          <p:cNvPr id="14" name="TextBox 13"/>
+          <p:cNvSpPr txBox="1"/>
+          <p:nvPr/>
+        </p:nvSpPr>
+        <p:spPr>
+          <a:xfrm>
+            <a:off x="8641080" y="3209544"/>
+            <a:ext cx="2926080" cy="411480"/>
+          </a:xfrm>
+          <a:prstGeom prst="rect">
+            <a:avLst/>
+          </a:prstGeom>
+          <a:noFill/>
+        </p:spPr>
+        <p:txBody>
+          <a:bodyPr wrap="square">
+            <a:spAutoFit/>
+          </a:bodyPr>
+          <a:lstStyle/>
+          <a:p>
+            <a:pPr algn="l"/>
+            <a:r>
+              <a:rPr sz="1100" b="0" i="0">
+                <a:solidFill>
+                  <a:srgbClr val="1A202C"/>
+                </a:solidFill>
+              </a:rPr>
+              <a:t>🔀  IF / Switch Node</a:t>
+            </a:r>
+          </a:p>
+        </p:txBody>
+      </p:sp>
+      <p:sp>
+        <p:nvSpPr>
+          <p:cNvPr id="15" name="TextBox 14"/>
+          <p:cNvSpPr txBox="1"/>
+          <p:nvPr/>
+        </p:nvSpPr>
+        <p:spPr>
+          <a:xfrm>
+            <a:off x="8641080" y="3685032"/>
+            <a:ext cx="2926080" cy="411480"/>
+          </a:xfrm>
+          <a:prstGeom prst="rect">
+            <a:avLst/>
+          </a:prstGeom>
+          <a:noFill/>
+        </p:spPr>
+        <p:txBody>
+          <a:bodyPr wrap="square">
+            <a:spAutoFit/>
+          </a:bodyPr>
+          <a:lstStyle/>
+          <a:p>
+            <a:pPr algn="l"/>
+            <a:r>
+              <a:rPr sz="1100" b="0" i="0">
+                <a:solidFill>
+                  <a:srgbClr val="1A202C"/>
+                </a:solidFill>
+              </a:rPr>
+              <a:t>⏳  Wait-Node (HitL)</a:t>
+            </a:r>
+          </a:p>
+        </p:txBody>
+      </p:sp>
+      <p:sp>
+        <p:nvSpPr>
+          <p:cNvPr id="16" name="TextBox 15"/>
+          <p:cNvSpPr txBox="1"/>
+          <p:nvPr/>
+        </p:nvSpPr>
+        <p:spPr>
+          <a:xfrm>
+            <a:off x="8641080" y="4160520"/>
+            <a:ext cx="2926080" cy="411480"/>
+          </a:xfrm>
+          <a:prstGeom prst="rect">
+            <a:avLst/>
+          </a:prstGeom>
+          <a:noFill/>
+        </p:spPr>
+        <p:txBody>
+          <a:bodyPr wrap="square">
+            <a:spAutoFit/>
+          </a:bodyPr>
+          <a:lstStyle/>
+          <a:p>
+            <a:pPr algn="l"/>
+            <a:r>
+              <a:rPr sz="1100" b="0" i="0">
+                <a:solidFill>
+                  <a:srgbClr val="1A202C"/>
+                </a:solidFill>
+              </a:rPr>
+              <a:t>📄  Google Docs</a:t>
+            </a:r>
+          </a:p>
+        </p:txBody>
+      </p:sp>
+      <p:sp>
+        <p:nvSpPr>
+          <p:cNvPr id="17" name="TextBox 16"/>
+          <p:cNvSpPr txBox="1"/>
+          <p:nvPr/>
+        </p:nvSpPr>
+        <p:spPr>
+          <a:xfrm>
+            <a:off x="8641080" y="4636008"/>
+            <a:ext cx="2926080" cy="411480"/>
+          </a:xfrm>
+          <a:prstGeom prst="rect">
+            <a:avLst/>
+          </a:prstGeom>
+          <a:noFill/>
+        </p:spPr>
+        <p:txBody>
+          <a:bodyPr wrap="square">
+            <a:spAutoFit/>
+          </a:bodyPr>
+          <a:lstStyle/>
+          <a:p>
+            <a:pPr algn="l"/>
+            <a:r>
+              <a:rPr sz="1100" b="0" i="0">
+                <a:solidFill>
+                  <a:srgbClr val="1A202C"/>
+                </a:solidFill>
+              </a:rPr>
+              <a:t>🔔  Webhook Trigger</a:t>
+            </a:r>
+          </a:p>
+        </p:txBody>
+      </p:sp>
+      <p:sp>
+        <p:nvSpPr>
+          <p:cNvPr id="18" name="TextBox 17"/>
+          <p:cNvSpPr txBox="1"/>
+          <p:nvPr/>
+        </p:nvSpPr>
+        <p:spPr>
+          <a:xfrm>
+            <a:off x="8641080" y="5111496"/>
+            <a:ext cx="2926080" cy="411480"/>
+          </a:xfrm>
+          <a:prstGeom prst="rect">
+            <a:avLst/>
+          </a:prstGeom>
+          <a:noFill/>
+        </p:spPr>
+        <p:txBody>
+          <a:bodyPr wrap="square">
+            <a:spAutoFit/>
+          </a:bodyPr>
+          <a:lstStyle/>
+          <a:p>
+            <a:pPr algn="l"/>
+            <a:r>
+              <a:rPr sz="1100" b="0" i="0">
+                <a:solidFill>
+                  <a:srgbClr val="1A202C"/>
+                </a:solidFill>
+              </a:rPr>
+              <a:t>💾  Daten speichern</a:t>
+            </a:r>
+          </a:p>
+        </p:txBody>
+      </p:sp>
+      <p:sp>
+        <p:nvSpPr>
+          <p:cNvPr id="19" name="TextBox 18"/>
+          <p:cNvSpPr txBox="1"/>
+          <p:nvPr/>
+        </p:nvSpPr>
+        <p:spPr>
+          <a:xfrm>
+            <a:off x="8641080" y="5586984"/>
+            <a:ext cx="2926080" cy="411480"/>
+          </a:xfrm>
+          <a:prstGeom prst="rect">
+            <a:avLst/>
+          </a:prstGeom>
+          <a:noFill/>
+        </p:spPr>
+        <p:txBody>
+          <a:bodyPr wrap="square">
+            <a:spAutoFit/>
+          </a:bodyPr>
+          <a:lstStyle/>
+          <a:p>
+            <a:pPr algn="l"/>
+            <a:r>
+              <a:rPr sz="1100" b="0" i="0">
+                <a:solidFill>
+                  <a:srgbClr val="1A202C"/>
+                </a:solidFill>
+              </a:rPr>
+              <a:t>✉️  Nachricht senden</a:t>
+            </a:r>
+          </a:p>
+        </p:txBody>
+      </p:sp>
+      <p:sp>
+        <p:nvSpPr>
+          <p:cNvPr id="20" name="Rectangle 19"/>
+          <p:cNvSpPr/>
+          <p:nvPr/>
+        </p:nvSpPr>
+        <p:spPr>
+          <a:xfrm>
+            <a:off x="457200" y="6291072"/>
+            <a:ext cx="11247120" cy="411480"/>
+          </a:xfrm>
+          <a:prstGeom prst="rect">
+            <a:avLst/>
+          </a:prstGeom>
+          <a:solidFill>
+            <a:srgbClr val="EAF7EE"/>
+          </a:solidFill>
+          <a:ln w="15240">
+            <a:solidFill>
+              <a:srgbClr val="38A169"/>
+            </a:solidFill>
+          </a:ln>
+        </p:spPr>
+        <p:style>
+          <a:lnRef idx="1">
+            <a:schemeClr val="accent1"/>
+          </a:lnRef>
+          <a:fillRef idx="3">
+            <a:schemeClr val="accent1"/>
+          </a:fillRef>
+          <a:effectRef idx="2">
+            <a:schemeClr val="accent1"/>
+          </a:effectRef>
+          <a:fontRef idx="minor">
+            <a:schemeClr val="lt1"/>
+          </a:fontRef>
+        </p:style>
+        <p:txBody>
+          <a:bodyPr rtlCol="0" anchor="ctr"/>
+          <a:lstStyle/>
+          <a:p>
+            <a:pPr algn="ctr"/>
+          </a:p>
+        </p:txBody>
+      </p:sp>
+      <p:sp>
+        <p:nvSpPr>
+          <p:cNvPr id="21" name="TextBox 20"/>
+          <p:cNvSpPr txBox="1"/>
+          <p:nvPr/>
+        </p:nvSpPr>
+        <p:spPr>
+          <a:xfrm>
+            <a:off x="594360" y="6355080"/>
+            <a:ext cx="10972800" cy="292608"/>
+          </a:xfrm>
+          <a:prstGeom prst="rect">
+            <a:avLst/>
+          </a:prstGeom>
+          <a:noFill/>
+        </p:spPr>
+        <p:txBody>
+          <a:bodyPr wrap="square">
+            <a:spAutoFit/>
+          </a:bodyPr>
+          <a:lstStyle/>
+          <a:p>
+            <a:pPr algn="l"/>
+            <a:r>
+              <a:rPr sz="1100" b="0" i="0">
+                <a:solidFill>
+                  <a:srgbClr val="38A169"/>
+                </a:solidFill>
+              </a:rPr>
+              <a:t>Status: HitL implementiert ✅ · 6 Kanäle ✅ · Kalkulation ✅ · Fehlerbehandlung ⏳ · Credentials Twilio/WA/TG ⏳</a:t>
             </a:r>
           </a:p>
         </p:txBody>

</xml_diff>

<commit_message>
Update Zapier screenshot slide to split L/R layout (slide 12)
Replaces single large placeholder with two side-by-side boxes for
left and right halves of the wide Zapier workflow screenshot, with
labels indicating which steps are visible in each half.

https://claude.ai/code/session_011nRTEEcniL9Xx4HAx6p44m
</commit_message>
<xml_diff>
--- a/KI_Auftragsannahme_DMAIC.pptx
+++ b/KI_Auftragsannahme_DMAIC.pptx
@@ -6039,7 +6039,7 @@
                   <a:srgbClr val="4A5568"/>
                 </a:solidFill>
               </a:rPr>
-              <a:t>Erster funktionsfähiger Workflow | Gmail → AI → Kalkulation → HitL → Versand</a:t>
+              <a:t>Erster Workflow | Gmail → AI Analyse → Kalkulation → Offerte → HitL → Versand</a:t>
             </a:r>
           </a:p>
         </p:txBody>
@@ -6052,8 +6052,8 @@
         </p:nvSpPr>
         <p:spPr>
           <a:xfrm>
-            <a:off x="457200" y="1280160"/>
-            <a:ext cx="11247120" cy="4526280"/>
+            <a:off x="274320" y="1261872"/>
+            <a:ext cx="5669280" cy="3931920"/>
           </a:xfrm>
           <a:prstGeom prst="rect">
             <a:avLst/>
@@ -6091,83 +6091,460 @@
       </p:sp>
       <p:sp>
         <p:nvSpPr>
-          <p:cNvPr id="6" name="TextBox 5"/>
-          <p:cNvSpPr txBox="1"/>
-          <p:nvPr/>
-        </p:nvSpPr>
-        <p:spPr>
-          <a:xfrm>
-            <a:off x="4114800" y="2286000"/>
-            <a:ext cx="4114800" cy="457200"/>
-          </a:xfrm>
-          <a:prstGeom prst="rect">
-            <a:avLst/>
-          </a:prstGeom>
-          <a:noFill/>
-        </p:spPr>
-        <p:txBody>
-          <a:bodyPr wrap="square">
-            <a:spAutoFit/>
-          </a:bodyPr>
+          <p:cNvPr id="6" name="Rectangle 5"/>
+          <p:cNvSpPr/>
+          <p:nvPr/>
+        </p:nvSpPr>
+        <p:spPr>
+          <a:xfrm>
+            <a:off x="274320" y="1261872"/>
+            <a:ext cx="5669280" cy="347472"/>
+          </a:xfrm>
+          <a:prstGeom prst="rect">
+            <a:avLst/>
+          </a:prstGeom>
+          <a:solidFill>
+            <a:srgbClr val="3182CE"/>
+          </a:solidFill>
+          <a:ln>
+            <a:noFill/>
+          </a:ln>
+        </p:spPr>
+        <p:style>
+          <a:lnRef idx="1">
+            <a:schemeClr val="accent1"/>
+          </a:lnRef>
+          <a:fillRef idx="3">
+            <a:schemeClr val="accent1"/>
+          </a:fillRef>
+          <a:effectRef idx="2">
+            <a:schemeClr val="accent1"/>
+          </a:effectRef>
+          <a:fontRef idx="minor">
+            <a:schemeClr val="lt1"/>
+          </a:fontRef>
+        </p:style>
+        <p:txBody>
+          <a:bodyPr rtlCol="0" anchor="ctr"/>
           <a:lstStyle/>
           <a:p>
             <a:pPr algn="ctr"/>
-            <a:r>
-              <a:rPr sz="1400" b="0" i="0">
+          </a:p>
+        </p:txBody>
+      </p:sp>
+      <p:sp>
+        <p:nvSpPr>
+          <p:cNvPr id="7" name="TextBox 6"/>
+          <p:cNvSpPr txBox="1"/>
+          <p:nvPr/>
+        </p:nvSpPr>
+        <p:spPr>
+          <a:xfrm>
+            <a:off x="411480" y="1298448"/>
+            <a:ext cx="5394960" cy="256032"/>
+          </a:xfrm>
+          <a:prstGeom prst="rect">
+            <a:avLst/>
+          </a:prstGeom>
+          <a:noFill/>
+        </p:spPr>
+        <p:txBody>
+          <a:bodyPr wrap="square">
+            <a:spAutoFit/>
+          </a:bodyPr>
+          <a:lstStyle/>
+          <a:p>
+            <a:pPr algn="l"/>
+            <a:r>
+              <a:rPr sz="1100" b="1" i="0">
+                <a:solidFill>
+                  <a:srgbClr val="FFFFFF"/>
+                </a:solidFill>
+              </a:rPr>
+              <a:t>Linke Hälfte des Screenshots</a:t>
+            </a:r>
+          </a:p>
+        </p:txBody>
+      </p:sp>
+      <p:sp>
+        <p:nvSpPr>
+          <p:cNvPr id="8" name="TextBox 7"/>
+          <p:cNvSpPr txBox="1"/>
+          <p:nvPr/>
+        </p:nvSpPr>
+        <p:spPr>
+          <a:xfrm>
+            <a:off x="1371600" y="2377440"/>
+            <a:ext cx="2926080" cy="640080"/>
+          </a:xfrm>
+          <a:prstGeom prst="rect">
+            <a:avLst/>
+          </a:prstGeom>
+          <a:noFill/>
+        </p:spPr>
+        <p:txBody>
+          <a:bodyPr wrap="square">
+            <a:spAutoFit/>
+          </a:bodyPr>
+          <a:lstStyle/>
+          <a:p>
+            <a:pPr algn="ctr"/>
+            <a:r>
+              <a:rPr sz="1200" b="0" i="1">
                 <a:solidFill>
                   <a:srgbClr val="4A5568"/>
                 </a:solidFill>
               </a:rPr>
-              <a:t>📸  Screenshot einfügen:</a:t>
-            </a:r>
-          </a:p>
-        </p:txBody>
-      </p:sp>
-      <p:sp>
-        <p:nvSpPr>
-          <p:cNvPr id="7" name="TextBox 6"/>
-          <p:cNvSpPr txBox="1"/>
-          <p:nvPr/>
-        </p:nvSpPr>
-        <p:spPr>
-          <a:xfrm>
-            <a:off x="3200400" y="2834640"/>
-            <a:ext cx="5943600" cy="822960"/>
-          </a:xfrm>
-          <a:prstGeom prst="rect">
-            <a:avLst/>
-          </a:prstGeom>
-          <a:noFill/>
-        </p:spPr>
-        <p:txBody>
-          <a:bodyPr wrap="square">
-            <a:spAutoFit/>
-          </a:bodyPr>
+              <a:t>📸  Screenshot hier einfügen
+(linke Hälfte zuschneiden)</a:t>
+            </a:r>
+          </a:p>
+        </p:txBody>
+      </p:sp>
+      <p:sp>
+        <p:nvSpPr>
+          <p:cNvPr id="9" name="TextBox 8"/>
+          <p:cNvSpPr txBox="1"/>
+          <p:nvPr/>
+        </p:nvSpPr>
+        <p:spPr>
+          <a:xfrm>
+            <a:off x="457200" y="3291840"/>
+            <a:ext cx="5303520" cy="1554480"/>
+          </a:xfrm>
+          <a:prstGeom prst="rect">
+            <a:avLst/>
+          </a:prstGeom>
+          <a:noFill/>
+        </p:spPr>
+        <p:txBody>
+          <a:bodyPr wrap="square">
+            <a:spAutoFit/>
+          </a:bodyPr>
+          <a:lstStyle/>
+          <a:p>
+            <a:pPr algn="l"/>
+            <a:r>
+              <a:rPr sz="1100" b="0" i="0">
+                <a:solidFill>
+                  <a:srgbClr val="4A5568"/>
+                </a:solidFill>
+              </a:rPr>
+              <a:t>Enthält:
+Step 1: Gmail Trigger
+Step 2: AI Auftragsanalyse
+Step 3: Path (vollständig/unvollständig)</a:t>
+            </a:r>
+          </a:p>
+        </p:txBody>
+      </p:sp>
+      <p:sp>
+        <p:nvSpPr>
+          <p:cNvPr id="10" name="Rectangle 9"/>
+          <p:cNvSpPr/>
+          <p:nvPr/>
+        </p:nvSpPr>
+        <p:spPr>
+          <a:xfrm>
+            <a:off x="6263640" y="1261872"/>
+            <a:ext cx="5669280" cy="3931920"/>
+          </a:xfrm>
+          <a:prstGeom prst="rect">
+            <a:avLst/>
+          </a:prstGeom>
+          <a:solidFill>
+            <a:srgbClr val="EDF2F7"/>
+          </a:solidFill>
+          <a:ln w="15240">
+            <a:solidFill>
+              <a:srgbClr val="CBD5E0"/>
+            </a:solidFill>
+          </a:ln>
+        </p:spPr>
+        <p:style>
+          <a:lnRef idx="1">
+            <a:schemeClr val="accent1"/>
+          </a:lnRef>
+          <a:fillRef idx="3">
+            <a:schemeClr val="accent1"/>
+          </a:fillRef>
+          <a:effectRef idx="2">
+            <a:schemeClr val="accent1"/>
+          </a:effectRef>
+          <a:fontRef idx="minor">
+            <a:schemeClr val="lt1"/>
+          </a:fontRef>
+        </p:style>
+        <p:txBody>
+          <a:bodyPr rtlCol="0" anchor="ctr"/>
           <a:lstStyle/>
           <a:p>
             <a:pPr algn="ctr"/>
-            <a:r>
-              <a:rPr sz="1300" b="0" i="1">
-                <a:solidFill>
-                  <a:srgbClr val="A0AEC0"/>
-                </a:solidFill>
-              </a:rPr>
-              <a:t>Zapier Workflow Übersicht
-(erster Screenshot aus Chatverlauf)</a:t>
-            </a:r>
-          </a:p>
-        </p:txBody>
-      </p:sp>
-      <p:sp>
-        <p:nvSpPr>
-          <p:cNvPr id="8" name="Rectangle 7"/>
+          </a:p>
+        </p:txBody>
+      </p:sp>
+      <p:sp>
+        <p:nvSpPr>
+          <p:cNvPr id="11" name="Rectangle 10"/>
           <p:cNvSpPr/>
           <p:nvPr/>
         </p:nvSpPr>
         <p:spPr>
           <a:xfrm>
-            <a:off x="457200" y="5943600"/>
-            <a:ext cx="2011680" cy="731520"/>
+            <a:off x="6263640" y="1261872"/>
+            <a:ext cx="5669280" cy="347472"/>
+          </a:xfrm>
+          <a:prstGeom prst="rect">
+            <a:avLst/>
+          </a:prstGeom>
+          <a:solidFill>
+            <a:srgbClr val="3182CE"/>
+          </a:solidFill>
+          <a:ln>
+            <a:noFill/>
+          </a:ln>
+        </p:spPr>
+        <p:style>
+          <a:lnRef idx="1">
+            <a:schemeClr val="accent1"/>
+          </a:lnRef>
+          <a:fillRef idx="3">
+            <a:schemeClr val="accent1"/>
+          </a:fillRef>
+          <a:effectRef idx="2">
+            <a:schemeClr val="accent1"/>
+          </a:effectRef>
+          <a:fontRef idx="minor">
+            <a:schemeClr val="lt1"/>
+          </a:fontRef>
+        </p:style>
+        <p:txBody>
+          <a:bodyPr rtlCol="0" anchor="ctr"/>
+          <a:lstStyle/>
+          <a:p>
+            <a:pPr algn="ctr"/>
+          </a:p>
+        </p:txBody>
+      </p:sp>
+      <p:sp>
+        <p:nvSpPr>
+          <p:cNvPr id="12" name="TextBox 11"/>
+          <p:cNvSpPr txBox="1"/>
+          <p:nvPr/>
+        </p:nvSpPr>
+        <p:spPr>
+          <a:xfrm>
+            <a:off x="6400800" y="1298448"/>
+            <a:ext cx="5394960" cy="256032"/>
+          </a:xfrm>
+          <a:prstGeom prst="rect">
+            <a:avLst/>
+          </a:prstGeom>
+          <a:noFill/>
+        </p:spPr>
+        <p:txBody>
+          <a:bodyPr wrap="square">
+            <a:spAutoFit/>
+          </a:bodyPr>
+          <a:lstStyle/>
+          <a:p>
+            <a:pPr algn="l"/>
+            <a:r>
+              <a:rPr sz="1100" b="1" i="0">
+                <a:solidFill>
+                  <a:srgbClr val="FFFFFF"/>
+                </a:solidFill>
+              </a:rPr>
+              <a:t>Rechte Hälfte des Screenshots</a:t>
+            </a:r>
+          </a:p>
+        </p:txBody>
+      </p:sp>
+      <p:sp>
+        <p:nvSpPr>
+          <p:cNvPr id="13" name="TextBox 12"/>
+          <p:cNvSpPr txBox="1"/>
+          <p:nvPr/>
+        </p:nvSpPr>
+        <p:spPr>
+          <a:xfrm>
+            <a:off x="7360920" y="2377440"/>
+            <a:ext cx="2926080" cy="640080"/>
+          </a:xfrm>
+          <a:prstGeom prst="rect">
+            <a:avLst/>
+          </a:prstGeom>
+          <a:noFill/>
+        </p:spPr>
+        <p:txBody>
+          <a:bodyPr wrap="square">
+            <a:spAutoFit/>
+          </a:bodyPr>
+          <a:lstStyle/>
+          <a:p>
+            <a:pPr algn="ctr"/>
+            <a:r>
+              <a:rPr sz="1200" b="0" i="1">
+                <a:solidFill>
+                  <a:srgbClr val="4A5568"/>
+                </a:solidFill>
+              </a:rPr>
+              <a:t>📸  Screenshot hier einfügen
+(rechte Hälfte zuschneiden)</a:t>
+            </a:r>
+          </a:p>
+        </p:txBody>
+      </p:sp>
+      <p:sp>
+        <p:nvSpPr>
+          <p:cNvPr id="14" name="TextBox 13"/>
+          <p:cNvSpPr txBox="1"/>
+          <p:nvPr/>
+        </p:nvSpPr>
+        <p:spPr>
+          <a:xfrm>
+            <a:off x="6446520" y="3291840"/>
+            <a:ext cx="5303520" cy="1554480"/>
+          </a:xfrm>
+          <a:prstGeom prst="rect">
+            <a:avLst/>
+          </a:prstGeom>
+          <a:noFill/>
+        </p:spPr>
+        <p:txBody>
+          <a:bodyPr wrap="square">
+            <a:spAutoFit/>
+          </a:bodyPr>
+          <a:lstStyle/>
+          <a:p>
+            <a:pPr algn="l"/>
+            <a:r>
+              <a:rPr sz="1100" b="0" i="0">
+                <a:solidFill>
+                  <a:srgbClr val="4A5568"/>
+                </a:solidFill>
+              </a:rPr>
+              <a:t>Enthält:
+Step 6: Kalkulation AI
+Step 7: Offerte AI
+Step 9: Human in the Loop
+Step 16: Rückfrage-E-Mail</a:t>
+            </a:r>
+          </a:p>
+        </p:txBody>
+      </p:sp>
+      <p:sp>
+        <p:nvSpPr>
+          <p:cNvPr id="15" name="TextBox 14"/>
+          <p:cNvSpPr txBox="1"/>
+          <p:nvPr/>
+        </p:nvSpPr>
+        <p:spPr>
+          <a:xfrm>
+            <a:off x="457200" y="5303520"/>
+            <a:ext cx="2286000" cy="320040"/>
+          </a:xfrm>
+          <a:prstGeom prst="rect">
+            <a:avLst/>
+          </a:prstGeom>
+          <a:noFill/>
+        </p:spPr>
+        <p:txBody>
+          <a:bodyPr wrap="square">
+            <a:spAutoFit/>
+          </a:bodyPr>
+          <a:lstStyle/>
+          <a:p>
+            <a:pPr algn="l"/>
+            <a:r>
+              <a:rPr sz="1100" b="1" i="0">
+                <a:solidFill>
+                  <a:srgbClr val="3182CE"/>
+                </a:solidFill>
+              </a:rPr>
+              <a:t>◀ Links</a:t>
+            </a:r>
+          </a:p>
+        </p:txBody>
+      </p:sp>
+      <p:sp>
+        <p:nvSpPr>
+          <p:cNvPr id="16" name="TextBox 15"/>
+          <p:cNvSpPr txBox="1"/>
+          <p:nvPr/>
+        </p:nvSpPr>
+        <p:spPr>
+          <a:xfrm>
+            <a:off x="9601200" y="5303520"/>
+            <a:ext cx="2286000" cy="320040"/>
+          </a:xfrm>
+          <a:prstGeom prst="rect">
+            <a:avLst/>
+          </a:prstGeom>
+          <a:noFill/>
+        </p:spPr>
+        <p:txBody>
+          <a:bodyPr wrap="square">
+            <a:spAutoFit/>
+          </a:bodyPr>
+          <a:lstStyle/>
+          <a:p>
+            <a:pPr algn="r"/>
+            <a:r>
+              <a:rPr sz="1100" b="1" i="0">
+                <a:solidFill>
+                  <a:srgbClr val="3182CE"/>
+                </a:solidFill>
+              </a:rPr>
+              <a:t>Rechts ▶</a:t>
+            </a:r>
+          </a:p>
+        </p:txBody>
+      </p:sp>
+      <p:sp>
+        <p:nvSpPr>
+          <p:cNvPr id="17" name="TextBox 16"/>
+          <p:cNvSpPr txBox="1"/>
+          <p:nvPr/>
+        </p:nvSpPr>
+        <p:spPr>
+          <a:xfrm>
+            <a:off x="457200" y="5349240"/>
+            <a:ext cx="11247120" cy="320040"/>
+          </a:xfrm>
+          <a:prstGeom prst="rect">
+            <a:avLst/>
+          </a:prstGeom>
+          <a:noFill/>
+        </p:spPr>
+        <p:txBody>
+          <a:bodyPr wrap="square">
+            <a:spAutoFit/>
+          </a:bodyPr>
+          <a:lstStyle/>
+          <a:p>
+            <a:pPr algn="ctr"/>
+            <a:r>
+              <a:rPr sz="1000" b="0" i="1">
+                <a:solidFill>
+                  <a:srgbClr val="4A5568"/>
+                </a:solidFill>
+              </a:rPr>
+              <a:t>Tipp: Screenshot in Bildbearbeitungsprogramm vertikal halbieren → je eine Hälfte in die Platzhalter ziehen</a:t>
+            </a:r>
+          </a:p>
+        </p:txBody>
+      </p:sp>
+      <p:sp>
+        <p:nvSpPr>
+          <p:cNvPr id="18" name="Rectangle 17"/>
+          <p:cNvSpPr/>
+          <p:nvPr/>
+        </p:nvSpPr>
+        <p:spPr>
+          <a:xfrm>
+            <a:off x="457200" y="5760720"/>
+            <a:ext cx="2011680" cy="685800"/>
           </a:xfrm>
           <a:prstGeom prst="rect">
             <a:avLst/>
@@ -6205,14 +6582,14 @@
       </p:sp>
       <p:sp>
         <p:nvSpPr>
-          <p:cNvPr id="9" name="TextBox 8"/>
-          <p:cNvSpPr txBox="1"/>
-          <p:nvPr/>
-        </p:nvSpPr>
-        <p:spPr>
-          <a:xfrm>
-            <a:off x="548640" y="5989320"/>
-            <a:ext cx="1828800" cy="274320"/>
+          <p:cNvPr id="19" name="TextBox 18"/>
+          <p:cNvSpPr txBox="1"/>
+          <p:nvPr/>
+        </p:nvSpPr>
+        <p:spPr>
+          <a:xfrm>
+            <a:off x="548640" y="5806440"/>
+            <a:ext cx="1828800" cy="256032"/>
           </a:xfrm>
           <a:prstGeom prst="rect">
             <a:avLst/>
@@ -6239,14 +6616,14 @@
       </p:sp>
       <p:sp>
         <p:nvSpPr>
-          <p:cNvPr id="10" name="TextBox 9"/>
-          <p:cNvSpPr txBox="1"/>
-          <p:nvPr/>
-        </p:nvSpPr>
-        <p:spPr>
-          <a:xfrm>
-            <a:off x="548640" y="6263640"/>
-            <a:ext cx="1828800" cy="320040"/>
+          <p:cNvPr id="20" name="TextBox 19"/>
+          <p:cNvSpPr txBox="1"/>
+          <p:nvPr/>
+        </p:nvSpPr>
+        <p:spPr>
+          <a:xfrm>
+            <a:off x="548640" y="6080760"/>
+            <a:ext cx="1828800" cy="292608"/>
           </a:xfrm>
           <a:prstGeom prst="rect">
             <a:avLst/>
@@ -6266,22 +6643,21 @@
                   <a:srgbClr val="4A5568"/>
                 </a:solidFill>
               </a:rPr>
-              <a:t>Gmail Trigger
-+ AI Analyse</a:t>
-            </a:r>
-          </a:p>
-        </p:txBody>
-      </p:sp>
-      <p:sp>
-        <p:nvSpPr>
-          <p:cNvPr id="11" name="Rectangle 10"/>
+              <a:t>Trigger + AI</a:t>
+            </a:r>
+          </a:p>
+        </p:txBody>
+      </p:sp>
+      <p:sp>
+        <p:nvSpPr>
+          <p:cNvPr id="21" name="Rectangle 20"/>
           <p:cNvSpPr/>
           <p:nvPr/>
         </p:nvSpPr>
         <p:spPr>
           <a:xfrm>
-            <a:off x="2624328" y="5943600"/>
-            <a:ext cx="2011680" cy="731520"/>
+            <a:off x="2624328" y="5760720"/>
+            <a:ext cx="2011680" cy="685800"/>
           </a:xfrm>
           <a:prstGeom prst="rect">
             <a:avLst/>
@@ -6319,14 +6695,14 @@
       </p:sp>
       <p:sp>
         <p:nvSpPr>
-          <p:cNvPr id="12" name="TextBox 11"/>
-          <p:cNvSpPr txBox="1"/>
-          <p:nvPr/>
-        </p:nvSpPr>
-        <p:spPr>
-          <a:xfrm>
-            <a:off x="2715768" y="5989320"/>
-            <a:ext cx="1828800" cy="274320"/>
+          <p:cNvPr id="22" name="TextBox 21"/>
+          <p:cNvSpPr txBox="1"/>
+          <p:nvPr/>
+        </p:nvSpPr>
+        <p:spPr>
+          <a:xfrm>
+            <a:off x="2715768" y="5806440"/>
+            <a:ext cx="1828800" cy="256032"/>
           </a:xfrm>
           <a:prstGeom prst="rect">
             <a:avLst/>
@@ -6353,14 +6729,14 @@
       </p:sp>
       <p:sp>
         <p:nvSpPr>
-          <p:cNvPr id="13" name="TextBox 12"/>
-          <p:cNvSpPr txBox="1"/>
-          <p:nvPr/>
-        </p:nvSpPr>
-        <p:spPr>
-          <a:xfrm>
-            <a:off x="2715768" y="6263640"/>
-            <a:ext cx="1828800" cy="320040"/>
+          <p:cNvPr id="23" name="TextBox 22"/>
+          <p:cNvSpPr txBox="1"/>
+          <p:nvPr/>
+        </p:nvSpPr>
+        <p:spPr>
+          <a:xfrm>
+            <a:off x="2715768" y="6080760"/>
+            <a:ext cx="1828800" cy="292608"/>
           </a:xfrm>
           <a:prstGeom prst="rect">
             <a:avLst/>
@@ -6380,22 +6756,21 @@
                   <a:srgbClr val="4A5568"/>
                 </a:solidFill>
               </a:rPr>
-              <a:t>Path: vollständig
-vs. unvollständig</a:t>
-            </a:r>
-          </a:p>
-        </p:txBody>
-      </p:sp>
-      <p:sp>
-        <p:nvSpPr>
-          <p:cNvPr id="14" name="Rectangle 13"/>
+              <a:t>Path</a:t>
+            </a:r>
+          </a:p>
+        </p:txBody>
+      </p:sp>
+      <p:sp>
+        <p:nvSpPr>
+          <p:cNvPr id="24" name="Rectangle 23"/>
           <p:cNvSpPr/>
           <p:nvPr/>
         </p:nvSpPr>
         <p:spPr>
           <a:xfrm>
-            <a:off x="4791456" y="5943600"/>
-            <a:ext cx="2011680" cy="731520"/>
+            <a:off x="4791456" y="5760720"/>
+            <a:ext cx="2011680" cy="685800"/>
           </a:xfrm>
           <a:prstGeom prst="rect">
             <a:avLst/>
@@ -6433,14 +6808,14 @@
       </p:sp>
       <p:sp>
         <p:nvSpPr>
-          <p:cNvPr id="15" name="TextBox 14"/>
-          <p:cNvSpPr txBox="1"/>
-          <p:nvPr/>
-        </p:nvSpPr>
-        <p:spPr>
-          <a:xfrm>
-            <a:off x="4882896" y="5989320"/>
-            <a:ext cx="1828800" cy="274320"/>
+          <p:cNvPr id="25" name="TextBox 24"/>
+          <p:cNvSpPr txBox="1"/>
+          <p:nvPr/>
+        </p:nvSpPr>
+        <p:spPr>
+          <a:xfrm>
+            <a:off x="4882896" y="5806440"/>
+            <a:ext cx="1828800" cy="256032"/>
           </a:xfrm>
           <a:prstGeom prst="rect">
             <a:avLst/>
@@ -6467,14 +6842,14 @@
       </p:sp>
       <p:sp>
         <p:nvSpPr>
-          <p:cNvPr id="16" name="TextBox 15"/>
-          <p:cNvSpPr txBox="1"/>
-          <p:nvPr/>
-        </p:nvSpPr>
-        <p:spPr>
-          <a:xfrm>
-            <a:off x="4882896" y="6263640"/>
-            <a:ext cx="1828800" cy="320040"/>
+          <p:cNvPr id="26" name="TextBox 25"/>
+          <p:cNvSpPr txBox="1"/>
+          <p:nvPr/>
+        </p:nvSpPr>
+        <p:spPr>
+          <a:xfrm>
+            <a:off x="4882896" y="6080760"/>
+            <a:ext cx="1828800" cy="292608"/>
           </a:xfrm>
           <a:prstGeom prst="rect">
             <a:avLst/>
@@ -6494,22 +6869,21 @@
                   <a:srgbClr val="4A5568"/>
                 </a:solidFill>
               </a:rPr>
-              <a:t>Kalkulation
-+ Offerte AI</a:t>
-            </a:r>
-          </a:p>
-        </p:txBody>
-      </p:sp>
-      <p:sp>
-        <p:nvSpPr>
-          <p:cNvPr id="17" name="Rectangle 16"/>
+              <a:t>Kalk. + Offerte</a:t>
+            </a:r>
+          </a:p>
+        </p:txBody>
+      </p:sp>
+      <p:sp>
+        <p:nvSpPr>
+          <p:cNvPr id="27" name="Rectangle 26"/>
           <p:cNvSpPr/>
           <p:nvPr/>
         </p:nvSpPr>
         <p:spPr>
           <a:xfrm>
-            <a:off x="6958584" y="5943600"/>
-            <a:ext cx="2011680" cy="731520"/>
+            <a:off x="6958584" y="5760720"/>
+            <a:ext cx="2011680" cy="685800"/>
           </a:xfrm>
           <a:prstGeom prst="rect">
             <a:avLst/>
@@ -6547,14 +6921,14 @@
       </p:sp>
       <p:sp>
         <p:nvSpPr>
-          <p:cNvPr id="18" name="TextBox 17"/>
-          <p:cNvSpPr txBox="1"/>
-          <p:nvPr/>
-        </p:nvSpPr>
-        <p:spPr>
-          <a:xfrm>
-            <a:off x="7050024" y="5989320"/>
-            <a:ext cx="1828800" cy="274320"/>
+          <p:cNvPr id="28" name="TextBox 27"/>
+          <p:cNvSpPr txBox="1"/>
+          <p:nvPr/>
+        </p:nvSpPr>
+        <p:spPr>
+          <a:xfrm>
+            <a:off x="7050024" y="5806440"/>
+            <a:ext cx="1828800" cy="256032"/>
           </a:xfrm>
           <a:prstGeom prst="rect">
             <a:avLst/>
@@ -6581,14 +6955,14 @@
       </p:sp>
       <p:sp>
         <p:nvSpPr>
-          <p:cNvPr id="19" name="TextBox 18"/>
-          <p:cNvSpPr txBox="1"/>
-          <p:nvPr/>
-        </p:nvSpPr>
-        <p:spPr>
-          <a:xfrm>
-            <a:off x="7050024" y="6263640"/>
-            <a:ext cx="1828800" cy="320040"/>
+          <p:cNvPr id="29" name="TextBox 28"/>
+          <p:cNvSpPr txBox="1"/>
+          <p:nvPr/>
+        </p:nvSpPr>
+        <p:spPr>
+          <a:xfrm>
+            <a:off x="7050024" y="6080760"/>
+            <a:ext cx="1828800" cy="292608"/>
           </a:xfrm>
           <a:prstGeom prst="rect">
             <a:avLst/>
@@ -6608,22 +6982,21 @@
                   <a:srgbClr val="4A5568"/>
                 </a:solidFill>
               </a:rPr>
-              <a:t>Human in
-the Loop</a:t>
-            </a:r>
-          </a:p>
-        </p:txBody>
-      </p:sp>
-      <p:sp>
-        <p:nvSpPr>
-          <p:cNvPr id="20" name="Rectangle 19"/>
+              <a:t>HitL</a:t>
+            </a:r>
+          </a:p>
+        </p:txBody>
+      </p:sp>
+      <p:sp>
+        <p:nvSpPr>
+          <p:cNvPr id="30" name="Rectangle 29"/>
           <p:cNvSpPr/>
           <p:nvPr/>
         </p:nvSpPr>
         <p:spPr>
           <a:xfrm>
-            <a:off x="9125712" y="5943600"/>
-            <a:ext cx="2011680" cy="731520"/>
+            <a:off x="9125712" y="5760720"/>
+            <a:ext cx="2011680" cy="685800"/>
           </a:xfrm>
           <a:prstGeom prst="rect">
             <a:avLst/>
@@ -6661,14 +7034,14 @@
       </p:sp>
       <p:sp>
         <p:nvSpPr>
-          <p:cNvPr id="21" name="TextBox 20"/>
-          <p:cNvSpPr txBox="1"/>
-          <p:nvPr/>
-        </p:nvSpPr>
-        <p:spPr>
-          <a:xfrm>
-            <a:off x="9217152" y="5989320"/>
-            <a:ext cx="1828800" cy="274320"/>
+          <p:cNvPr id="31" name="TextBox 30"/>
+          <p:cNvSpPr txBox="1"/>
+          <p:nvPr/>
+        </p:nvSpPr>
+        <p:spPr>
+          <a:xfrm>
+            <a:off x="9217152" y="5806440"/>
+            <a:ext cx="1828800" cy="256032"/>
           </a:xfrm>
           <a:prstGeom prst="rect">
             <a:avLst/>
@@ -6695,14 +7068,14 @@
       </p:sp>
       <p:sp>
         <p:nvSpPr>
-          <p:cNvPr id="22" name="TextBox 21"/>
-          <p:cNvSpPr txBox="1"/>
-          <p:nvPr/>
-        </p:nvSpPr>
-        <p:spPr>
-          <a:xfrm>
-            <a:off x="9217152" y="6263640"/>
-            <a:ext cx="1828800" cy="320040"/>
+          <p:cNvPr id="32" name="TextBox 31"/>
+          <p:cNvSpPr txBox="1"/>
+          <p:nvPr/>
+        </p:nvSpPr>
+        <p:spPr>
+          <a:xfrm>
+            <a:off x="9217152" y="6080760"/>
+            <a:ext cx="1828800" cy="292608"/>
           </a:xfrm>
           <a:prstGeom prst="rect">
             <a:avLst/>
@@ -6722,8 +7095,7 @@
                   <a:srgbClr val="4A5568"/>
                 </a:solidFill>
               </a:rPr>
-              <a:t>Rückfrage
-E-Mail</a:t>
+              <a:t>Rückfrage</a:t>
             </a:r>
           </a:p>
         </p:txBody>

</xml_diff>